<commit_message>
Add animation to pptx
</commit_message>
<xml_diff>
--- a/CrianzaRespetuosa.pptx
+++ b/CrianzaRespetuosa.pptx
@@ -191,7 +191,7 @@
 <file path=ppt/charts/chart1.xml><?xml version="1.0" encoding="utf-8"?>
 <c:chartSpace xmlns:c="http://schemas.openxmlformats.org/drawingml/2006/chart" xmlns:a="http://schemas.openxmlformats.org/drawingml/2006/main" xmlns:r="http://schemas.openxmlformats.org/officeDocument/2006/relationships" xmlns:c16r2="http://schemas.microsoft.com/office/drawing/2015/06/chart">
   <c:date1904 val="0"/>
-  <c:lang val="en-US"/>
+  <c:lang val="es-ES"/>
   <c:roundedCorners val="1"/>
   <c:style val="2"/>
   <c:chart>
@@ -561,7 +561,7 @@
           </a:lstStyle>
           <a:p>
             <a:fld id="{9FD07F91-E64D-4646-9EEF-09B568070F09}" type="datetimeFigureOut">
-              <a:t>3/30/2026</a:t>
+              <a:t>30/03/2026</a:t>
             </a:fld>
             <a:endParaRPr lang="en-US"/>
           </a:p>
@@ -718,7 +718,7 @@
           </a:lstStyle>
           <a:p>
             <a:fld id="{A69E24B3-206D-4CEC-9C05-171CD157F221}" type="slidenum">
-              <a:t>‹#›</a:t>
+              <a:t>‹Nº›</a:t>
             </a:fld>
             <a:endParaRPr lang="en-US"/>
           </a:p>
@@ -1780,6 +1780,13 @@
             <a:prstDash val="solid"/>
           </a:ln>
         </p:spPr>
+        <p:txBody>
+          <a:bodyPr/>
+          <a:lstStyle/>
+          <a:p>
+            <a:endParaRPr lang="es-CO"/>
+          </a:p>
+        </p:txBody>
       </p:sp>
       <p:sp>
         <p:nvSpPr>
@@ -1809,6 +1816,13 @@
             <a:prstDash val="solid"/>
           </a:ln>
         </p:spPr>
+        <p:txBody>
+          <a:bodyPr/>
+          <a:lstStyle/>
+          <a:p>
+            <a:endParaRPr lang="es-CO"/>
+          </a:p>
+        </p:txBody>
       </p:sp>
       <p:sp>
         <p:nvSpPr>
@@ -1834,6 +1848,52 @@
             <a:prstDash val="solid"/>
           </a:ln>
         </p:spPr>
+        <p:txBody>
+          <a:bodyPr/>
+          <a:lstStyle/>
+          <a:p>
+            <a:endParaRPr lang="es-CO"/>
+          </a:p>
+        </p:txBody>
+      </p:sp>
+      <p:sp>
+        <p:nvSpPr>
+          <p:cNvPr id="7" name="Text 5"/>
+          <p:cNvSpPr/>
+          <p:nvPr/>
+        </p:nvSpPr>
+        <p:spPr>
+          <a:xfrm>
+            <a:off x="685800" y="1417320"/>
+            <a:ext cx="5303520" cy="777240"/>
+          </a:xfrm>
+          <a:prstGeom prst="rect">
+            <a:avLst/>
+          </a:prstGeom>
+          <a:noFill/>
+          <a:ln/>
+        </p:spPr>
+        <p:txBody>
+          <a:bodyPr wrap="square" rtlCol="0" anchor="ctr"/>
+          <a:lstStyle/>
+          <a:p>
+            <a:pPr marL="0" indent="0" algn="l">
+              <a:buNone/>
+            </a:pPr>
+            <a:r>
+              <a:rPr lang="en-US" sz="4000" dirty="0">
+                <a:solidFill>
+                  <a:srgbClr val="FFFFFF"/>
+                </a:solidFill>
+                <a:latin typeface="Calibri Light" pitchFamily="34" charset="0"/>
+                <a:ea typeface="Calibri Light" pitchFamily="34" charset="-122"/>
+                <a:cs typeface="Calibri Light" pitchFamily="34" charset="-120"/>
+              </a:rPr>
+              <a:t>Crianza Respetuosa</a:t>
+            </a:r>
+            <a:endParaRPr lang="en-US" sz="4000" dirty="0"/>
+          </a:p>
+        </p:txBody>
       </p:sp>
       <p:sp>
         <p:nvSpPr>
@@ -1859,6 +1919,13 @@
             <a:prstDash val="solid"/>
           </a:ln>
         </p:spPr>
+        <p:txBody>
+          <a:bodyPr/>
+          <a:lstStyle/>
+          <a:p>
+            <a:endParaRPr lang="es-CO" dirty="0"/>
+          </a:p>
+        </p:txBody>
       </p:sp>
       <p:sp>
         <p:nvSpPr>
@@ -1896,45 +1963,6 @@
               <a:t>EDUCACION INICIAL</a:t>
             </a:r>
             <a:endParaRPr lang="en-US" sz="850" dirty="0"/>
-          </a:p>
-        </p:txBody>
-      </p:sp>
-      <p:sp>
-        <p:nvSpPr>
-          <p:cNvPr id="7" name="Text 5"/>
-          <p:cNvSpPr/>
-          <p:nvPr/>
-        </p:nvSpPr>
-        <p:spPr>
-          <a:xfrm>
-            <a:off x="685800" y="1417320"/>
-            <a:ext cx="5303520" cy="777240"/>
-          </a:xfrm>
-          <a:prstGeom prst="rect">
-            <a:avLst/>
-          </a:prstGeom>
-          <a:noFill/>
-          <a:ln/>
-        </p:spPr>
-        <p:txBody>
-          <a:bodyPr wrap="square" rtlCol="0" anchor="ctr"/>
-          <a:lstStyle/>
-          <a:p>
-            <a:pPr marL="0" indent="0" algn="l">
-              <a:buNone/>
-            </a:pPr>
-            <a:r>
-              <a:rPr lang="en-US" sz="4000" dirty="0">
-                <a:solidFill>
-                  <a:srgbClr val="FFFFFF"/>
-                </a:solidFill>
-                <a:latin typeface="Calibri Light" pitchFamily="34" charset="0"/>
-                <a:ea typeface="Calibri Light" pitchFamily="34" charset="-122"/>
-                <a:cs typeface="Calibri Light" pitchFamily="34" charset="-120"/>
-              </a:rPr>
-              <a:t>Crianza Respetuosa</a:t>
-            </a:r>
-            <a:endParaRPr lang="en-US" sz="4000" dirty="0"/>
           </a:p>
         </p:txBody>
       </p:sp>
@@ -2042,7 +2070,7 @@
                 <a:ea typeface="Calibri"/>
                 <a:cs typeface="Calibri"/>
               </a:rPr>
-              <a:t>acompanar</a:t>
+              <a:t>acompañar</a:t>
             </a:r>
             <a:r>
               <a:rPr lang="en-US" sz="1250" dirty="0">
@@ -2075,9 +2103,20 @@
                 <a:ea typeface="Calibri"/>
                 <a:cs typeface="Calibri"/>
               </a:rPr>
-              <a:t> 3 anos</a:t>
+              <a:t> 3 </a:t>
             </a:r>
-            <a:endParaRPr lang="en-US" sz="1250" dirty="0" err="1">
+            <a:r>
+              <a:rPr lang="en-US" sz="1250" dirty="0" err="1">
+                <a:solidFill>
+                  <a:srgbClr val="AABFB0"/>
+                </a:solidFill>
+                <a:latin typeface="Calibri"/>
+                <a:ea typeface="Calibri"/>
+                <a:cs typeface="Calibri"/>
+              </a:rPr>
+              <a:t>años</a:t>
+            </a:r>
+            <a:endParaRPr lang="en-US" sz="1250" dirty="0">
               <a:ea typeface="Calibri"/>
               <a:cs typeface="Calibri"/>
             </a:endParaRPr>
@@ -2106,6 +2145,13 @@
             <a:prstDash val="solid"/>
           </a:ln>
         </p:spPr>
+        <p:txBody>
+          <a:bodyPr/>
+          <a:lstStyle/>
+          <a:p>
+            <a:endParaRPr lang="es-CO"/>
+          </a:p>
+        </p:txBody>
       </p:sp>
       <p:sp>
         <p:nvSpPr>
@@ -2181,6 +2227,13 @@
             <a:prstDash val="solid"/>
           </a:ln>
         </p:spPr>
+        <p:txBody>
+          <a:bodyPr/>
+          <a:lstStyle/>
+          <a:p>
+            <a:endParaRPr lang="es-CO"/>
+          </a:p>
+        </p:txBody>
       </p:sp>
       <p:sp>
         <p:nvSpPr>
@@ -2210,6 +2263,13 @@
             <a:prstDash val="solid"/>
           </a:ln>
         </p:spPr>
+        <p:txBody>
+          <a:bodyPr/>
+          <a:lstStyle/>
+          <a:p>
+            <a:endParaRPr lang="es-CO"/>
+          </a:p>
+        </p:txBody>
       </p:sp>
       <p:sp>
         <p:nvSpPr>
@@ -2239,6 +2299,13 @@
             <a:prstDash val="solid"/>
           </a:ln>
         </p:spPr>
+        <p:txBody>
+          <a:bodyPr/>
+          <a:lstStyle/>
+          <a:p>
+            <a:endParaRPr lang="es-CO"/>
+          </a:p>
+        </p:txBody>
       </p:sp>
       <p:sp>
         <p:nvSpPr>
@@ -2268,6 +2335,13 @@
             <a:prstDash val="solid"/>
           </a:ln>
         </p:spPr>
+        <p:txBody>
+          <a:bodyPr/>
+          <a:lstStyle/>
+          <a:p>
+            <a:endParaRPr lang="es-CO"/>
+          </a:p>
+        </p:txBody>
       </p:sp>
       <p:sp>
         <p:nvSpPr>
@@ -2297,6 +2371,13 @@
             <a:prstDash val="solid"/>
           </a:ln>
         </p:spPr>
+        <p:txBody>
+          <a:bodyPr/>
+          <a:lstStyle/>
+          <a:p>
+            <a:endParaRPr lang="es-CO"/>
+          </a:p>
+        </p:txBody>
       </p:sp>
       <p:sp>
         <p:nvSpPr>
@@ -2326,6 +2407,13 @@
             <a:prstDash val="solid"/>
           </a:ln>
         </p:spPr>
+        <p:txBody>
+          <a:bodyPr/>
+          <a:lstStyle/>
+          <a:p>
+            <a:endParaRPr lang="es-CO"/>
+          </a:p>
+        </p:txBody>
       </p:sp>
       <p:sp>
         <p:nvSpPr>
@@ -2355,6 +2443,13 @@
             <a:prstDash val="solid"/>
           </a:ln>
         </p:spPr>
+        <p:txBody>
+          <a:bodyPr/>
+          <a:lstStyle/>
+          <a:p>
+            <a:endParaRPr lang="es-CO"/>
+          </a:p>
+        </p:txBody>
       </p:sp>
       <p:sp>
         <p:nvSpPr>
@@ -2384,6 +2479,13 @@
             <a:prstDash val="solid"/>
           </a:ln>
         </p:spPr>
+        <p:txBody>
+          <a:bodyPr/>
+          <a:lstStyle/>
+          <a:p>
+            <a:endParaRPr lang="es-CO"/>
+          </a:p>
+        </p:txBody>
       </p:sp>
       <p:sp>
         <p:nvSpPr>
@@ -2413,6 +2515,13 @@
             <a:prstDash val="solid"/>
           </a:ln>
         </p:spPr>
+        <p:txBody>
+          <a:bodyPr/>
+          <a:lstStyle/>
+          <a:p>
+            <a:endParaRPr lang="es-CO"/>
+          </a:p>
+        </p:txBody>
       </p:sp>
       <p:sp>
         <p:nvSpPr>
@@ -2442,6 +2551,13 @@
             <a:prstDash val="solid"/>
           </a:ln>
         </p:spPr>
+        <p:txBody>
+          <a:bodyPr/>
+          <a:lstStyle/>
+          <a:p>
+            <a:endParaRPr lang="es-CO"/>
+          </a:p>
+        </p:txBody>
       </p:sp>
       <p:sp>
         <p:nvSpPr>
@@ -2471,6 +2587,13 @@
             <a:prstDash val="solid"/>
           </a:ln>
         </p:spPr>
+        <p:txBody>
+          <a:bodyPr/>
+          <a:lstStyle/>
+          <a:p>
+            <a:endParaRPr lang="es-CO"/>
+          </a:p>
+        </p:txBody>
       </p:sp>
       <p:sp>
         <p:nvSpPr>
@@ -2500,16 +2623,23 @@
             <a:prstDash val="solid"/>
           </a:ln>
         </p:spPr>
-      </p:sp>
-      <p:sp>
-        <p:nvSpPr>
-          <p:cNvPr id="24" name="Shape 22"/>
-          <p:cNvSpPr/>
-          <p:nvPr/>
-        </p:nvSpPr>
-        <p:spPr>
-          <a:xfrm>
-            <a:off x="137160" y="996696"/>
+        <p:txBody>
+          <a:bodyPr/>
+          <a:lstStyle/>
+          <a:p>
+            <a:endParaRPr lang="es-CO"/>
+          </a:p>
+        </p:txBody>
+      </p:sp>
+      <p:sp>
+        <p:nvSpPr>
+          <p:cNvPr id="26" name="Shape 24"/>
+          <p:cNvSpPr/>
+          <p:nvPr/>
+        </p:nvSpPr>
+        <p:spPr>
+          <a:xfrm>
+            <a:off x="649224" y="996696"/>
             <a:ext cx="64008" cy="64008"/>
           </a:xfrm>
           <a:prstGeom prst="ellipse">
@@ -2529,16 +2659,23 @@
             <a:prstDash val="solid"/>
           </a:ln>
         </p:spPr>
-      </p:sp>
-      <p:sp>
-        <p:nvSpPr>
-          <p:cNvPr id="25" name="Shape 23"/>
-          <p:cNvSpPr/>
-          <p:nvPr/>
-        </p:nvSpPr>
-        <p:spPr>
-          <a:xfrm>
-            <a:off x="393192" y="996696"/>
+        <p:txBody>
+          <a:bodyPr/>
+          <a:lstStyle/>
+          <a:p>
+            <a:endParaRPr lang="es-CO"/>
+          </a:p>
+        </p:txBody>
+      </p:sp>
+      <p:sp>
+        <p:nvSpPr>
+          <p:cNvPr id="24" name="Shape 22"/>
+          <p:cNvSpPr/>
+          <p:nvPr/>
+        </p:nvSpPr>
+        <p:spPr>
+          <a:xfrm>
+            <a:off x="137160" y="996696"/>
             <a:ext cx="64008" cy="64008"/>
           </a:xfrm>
           <a:prstGeom prst="ellipse">
@@ -2558,16 +2695,23 @@
             <a:prstDash val="solid"/>
           </a:ln>
         </p:spPr>
-      </p:sp>
-      <p:sp>
-        <p:nvSpPr>
-          <p:cNvPr id="26" name="Shape 24"/>
-          <p:cNvSpPr/>
-          <p:nvPr/>
-        </p:nvSpPr>
-        <p:spPr>
-          <a:xfrm>
-            <a:off x="649224" y="996696"/>
+        <p:txBody>
+          <a:bodyPr/>
+          <a:lstStyle/>
+          <a:p>
+            <a:endParaRPr lang="es-CO"/>
+          </a:p>
+        </p:txBody>
+      </p:sp>
+      <p:sp>
+        <p:nvSpPr>
+          <p:cNvPr id="27" name="Shape 25"/>
+          <p:cNvSpPr/>
+          <p:nvPr/>
+        </p:nvSpPr>
+        <p:spPr>
+          <a:xfrm>
+            <a:off x="905256" y="996696"/>
             <a:ext cx="64008" cy="64008"/>
           </a:xfrm>
           <a:prstGeom prst="ellipse">
@@ -2587,16 +2731,23 @@
             <a:prstDash val="solid"/>
           </a:ln>
         </p:spPr>
-      </p:sp>
-      <p:sp>
-        <p:nvSpPr>
-          <p:cNvPr id="27" name="Shape 25"/>
-          <p:cNvSpPr/>
-          <p:nvPr/>
-        </p:nvSpPr>
-        <p:spPr>
-          <a:xfrm>
-            <a:off x="905256" y="996696"/>
+        <p:txBody>
+          <a:bodyPr/>
+          <a:lstStyle/>
+          <a:p>
+            <a:endParaRPr lang="es-CO"/>
+          </a:p>
+        </p:txBody>
+      </p:sp>
+      <p:sp>
+        <p:nvSpPr>
+          <p:cNvPr id="25" name="Shape 23"/>
+          <p:cNvSpPr/>
+          <p:nvPr/>
+        </p:nvSpPr>
+        <p:spPr>
+          <a:xfrm>
+            <a:off x="393192" y="996696"/>
             <a:ext cx="64008" cy="64008"/>
           </a:xfrm>
           <a:prstGeom prst="ellipse">
@@ -2616,12 +2767,358 @@
             <a:prstDash val="solid"/>
           </a:ln>
         </p:spPr>
+        <p:txBody>
+          <a:bodyPr/>
+          <a:lstStyle/>
+          <a:p>
+            <a:endParaRPr lang="es-CO"/>
+          </a:p>
+        </p:txBody>
       </p:sp>
     </p:spTree>
   </p:cSld>
   <p:clrMapOvr>
     <a:masterClrMapping/>
   </p:clrMapOvr>
+  <mc:AlternateContent xmlns:mc="http://schemas.openxmlformats.org/markup-compatibility/2006">
+    <mc:Choice xmlns:p14="http://schemas.microsoft.com/office/powerpoint/2010/main" Requires="p14">
+      <p:transition spd="slow" p14:dur="1200">
+        <p:dissolve/>
+      </p:transition>
+    </mc:Choice>
+    <mc:Fallback>
+      <p:transition spd="slow">
+        <p:dissolve/>
+      </p:transition>
+    </mc:Fallback>
+  </mc:AlternateContent>
+  <p:timing>
+    <p:tnLst>
+      <p:par>
+        <p:cTn id="1" dur="indefinite" restart="never" nodeType="tmRoot">
+          <p:childTnLst>
+            <p:seq concurrent="1" nextAc="seek">
+              <p:cTn id="2" dur="indefinite" nodeType="mainSeq">
+                <p:childTnLst>
+                  <p:par>
+                    <p:cTn id="3" fill="hold">
+                      <p:stCondLst>
+                        <p:cond delay="indefinite"/>
+                        <p:cond evt="onBegin" delay="0">
+                          <p:tn val="2"/>
+                        </p:cond>
+                      </p:stCondLst>
+                      <p:childTnLst>
+                        <p:par>
+                          <p:cTn id="4" fill="hold">
+                            <p:stCondLst>
+                              <p:cond delay="0"/>
+                            </p:stCondLst>
+                            <p:childTnLst>
+                              <p:par>
+                                <p:cTn id="5" presetID="2" presetClass="entr" presetSubtype="1" fill="hold" grpId="0" nodeType="withEffect">
+                                  <p:stCondLst>
+                                    <p:cond delay="0"/>
+                                  </p:stCondLst>
+                                  <p:childTnLst>
+                                    <p:set>
+                                      <p:cBhvr>
+                                        <p:cTn id="6" dur="1" fill="hold">
+                                          <p:stCondLst>
+                                            <p:cond delay="0"/>
+                                          </p:stCondLst>
+                                        </p:cTn>
+                                        <p:tgtEl>
+                                          <p:spTgt spid="5"/>
+                                        </p:tgtEl>
+                                        <p:attrNameLst>
+                                          <p:attrName>style.visibility</p:attrName>
+                                        </p:attrNameLst>
+                                      </p:cBhvr>
+                                      <p:to>
+                                        <p:strVal val="visible"/>
+                                      </p:to>
+                                    </p:set>
+                                    <p:anim calcmode="lin" valueType="num">
+                                      <p:cBhvr additive="base">
+                                        <p:cTn id="7" dur="500" fill="hold"/>
+                                        <p:tgtEl>
+                                          <p:spTgt spid="5"/>
+                                        </p:tgtEl>
+                                        <p:attrNameLst>
+                                          <p:attrName>ppt_x</p:attrName>
+                                        </p:attrNameLst>
+                                      </p:cBhvr>
+                                      <p:tavLst>
+                                        <p:tav tm="0">
+                                          <p:val>
+                                            <p:strVal val="#ppt_x"/>
+                                          </p:val>
+                                        </p:tav>
+                                        <p:tav tm="100000">
+                                          <p:val>
+                                            <p:strVal val="#ppt_x"/>
+                                          </p:val>
+                                        </p:tav>
+                                      </p:tavLst>
+                                    </p:anim>
+                                    <p:anim calcmode="lin" valueType="num">
+                                      <p:cBhvr additive="base">
+                                        <p:cTn id="8" dur="500" fill="hold"/>
+                                        <p:tgtEl>
+                                          <p:spTgt spid="5"/>
+                                        </p:tgtEl>
+                                        <p:attrNameLst>
+                                          <p:attrName>ppt_y</p:attrName>
+                                        </p:attrNameLst>
+                                      </p:cBhvr>
+                                      <p:tavLst>
+                                        <p:tav tm="0">
+                                          <p:val>
+                                            <p:strVal val="0-#ppt_h/2"/>
+                                          </p:val>
+                                        </p:tav>
+                                        <p:tav tm="100000">
+                                          <p:val>
+                                            <p:strVal val="#ppt_y"/>
+                                          </p:val>
+                                        </p:tav>
+                                      </p:tavLst>
+                                    </p:anim>
+                                  </p:childTnLst>
+                                </p:cTn>
+                              </p:par>
+                              <p:par>
+                                <p:cTn id="9" presetID="2" presetClass="entr" presetSubtype="1" fill="hold" grpId="0" nodeType="withEffect">
+                                  <p:stCondLst>
+                                    <p:cond delay="0"/>
+                                  </p:stCondLst>
+                                  <p:childTnLst>
+                                    <p:set>
+                                      <p:cBhvr>
+                                        <p:cTn id="10" dur="1" fill="hold">
+                                          <p:stCondLst>
+                                            <p:cond delay="0"/>
+                                          </p:stCondLst>
+                                        </p:cTn>
+                                        <p:tgtEl>
+                                          <p:spTgt spid="6"/>
+                                        </p:tgtEl>
+                                        <p:attrNameLst>
+                                          <p:attrName>style.visibility</p:attrName>
+                                        </p:attrNameLst>
+                                      </p:cBhvr>
+                                      <p:to>
+                                        <p:strVal val="visible"/>
+                                      </p:to>
+                                    </p:set>
+                                    <p:anim calcmode="lin" valueType="num">
+                                      <p:cBhvr additive="base">
+                                        <p:cTn id="11" dur="500" fill="hold"/>
+                                        <p:tgtEl>
+                                          <p:spTgt spid="6"/>
+                                        </p:tgtEl>
+                                        <p:attrNameLst>
+                                          <p:attrName>ppt_x</p:attrName>
+                                        </p:attrNameLst>
+                                      </p:cBhvr>
+                                      <p:tavLst>
+                                        <p:tav tm="0">
+                                          <p:val>
+                                            <p:strVal val="#ppt_x"/>
+                                          </p:val>
+                                        </p:tav>
+                                        <p:tav tm="100000">
+                                          <p:val>
+                                            <p:strVal val="#ppt_x"/>
+                                          </p:val>
+                                        </p:tav>
+                                      </p:tavLst>
+                                    </p:anim>
+                                    <p:anim calcmode="lin" valueType="num">
+                                      <p:cBhvr additive="base">
+                                        <p:cTn id="12" dur="500" fill="hold"/>
+                                        <p:tgtEl>
+                                          <p:spTgt spid="6"/>
+                                        </p:tgtEl>
+                                        <p:attrNameLst>
+                                          <p:attrName>ppt_y</p:attrName>
+                                        </p:attrNameLst>
+                                      </p:cBhvr>
+                                      <p:tavLst>
+                                        <p:tav tm="0">
+                                          <p:val>
+                                            <p:strVal val="0-#ppt_h/2"/>
+                                          </p:val>
+                                        </p:tav>
+                                        <p:tav tm="100000">
+                                          <p:val>
+                                            <p:strVal val="#ppt_y"/>
+                                          </p:val>
+                                        </p:tav>
+                                      </p:tavLst>
+                                    </p:anim>
+                                  </p:childTnLst>
+                                </p:cTn>
+                              </p:par>
+                            </p:childTnLst>
+                          </p:cTn>
+                        </p:par>
+                        <p:par>
+                          <p:cTn id="13" fill="hold">
+                            <p:stCondLst>
+                              <p:cond delay="500"/>
+                            </p:stCondLst>
+                            <p:childTnLst>
+                              <p:par>
+                                <p:cTn id="14" presetID="10" presetClass="entr" presetSubtype="0" fill="hold" grpId="0" nodeType="afterEffect">
+                                  <p:stCondLst>
+                                    <p:cond delay="0"/>
+                                  </p:stCondLst>
+                                  <p:childTnLst>
+                                    <p:set>
+                                      <p:cBhvr>
+                                        <p:cTn id="15" dur="1" fill="hold">
+                                          <p:stCondLst>
+                                            <p:cond delay="0"/>
+                                          </p:stCondLst>
+                                        </p:cTn>
+                                        <p:tgtEl>
+                                          <p:spTgt spid="7"/>
+                                        </p:tgtEl>
+                                        <p:attrNameLst>
+                                          <p:attrName>style.visibility</p:attrName>
+                                        </p:attrNameLst>
+                                      </p:cBhvr>
+                                      <p:to>
+                                        <p:strVal val="visible"/>
+                                      </p:to>
+                                    </p:set>
+                                    <p:animEffect transition="in" filter="fade">
+                                      <p:cBhvr>
+                                        <p:cTn id="16" dur="500"/>
+                                        <p:tgtEl>
+                                          <p:spTgt spid="7"/>
+                                        </p:tgtEl>
+                                      </p:cBhvr>
+                                    </p:animEffect>
+                                  </p:childTnLst>
+                                </p:cTn>
+                              </p:par>
+                              <p:par>
+                                <p:cTn id="17" presetID="10" presetClass="entr" presetSubtype="0" fill="hold" grpId="0" nodeType="withEffect">
+                                  <p:stCondLst>
+                                    <p:cond delay="0"/>
+                                  </p:stCondLst>
+                                  <p:childTnLst>
+                                    <p:set>
+                                      <p:cBhvr>
+                                        <p:cTn id="18" dur="1" fill="hold">
+                                          <p:stCondLst>
+                                            <p:cond delay="0"/>
+                                          </p:stCondLst>
+                                        </p:cTn>
+                                        <p:tgtEl>
+                                          <p:spTgt spid="8"/>
+                                        </p:tgtEl>
+                                        <p:attrNameLst>
+                                          <p:attrName>style.visibility</p:attrName>
+                                        </p:attrNameLst>
+                                      </p:cBhvr>
+                                      <p:to>
+                                        <p:strVal val="visible"/>
+                                      </p:to>
+                                    </p:set>
+                                    <p:animEffect transition="in" filter="fade">
+                                      <p:cBhvr>
+                                        <p:cTn id="19" dur="500"/>
+                                        <p:tgtEl>
+                                          <p:spTgt spid="8"/>
+                                        </p:tgtEl>
+                                      </p:cBhvr>
+                                    </p:animEffect>
+                                  </p:childTnLst>
+                                </p:cTn>
+                              </p:par>
+                            </p:childTnLst>
+                          </p:cTn>
+                        </p:par>
+                        <p:par>
+                          <p:cTn id="20" fill="hold">
+                            <p:stCondLst>
+                              <p:cond delay="1000"/>
+                            </p:stCondLst>
+                            <p:childTnLst>
+                              <p:par>
+                                <p:cTn id="21" presetID="10" presetClass="entr" presetSubtype="0" fill="hold" grpId="0" nodeType="afterEffect">
+                                  <p:stCondLst>
+                                    <p:cond delay="0"/>
+                                  </p:stCondLst>
+                                  <p:childTnLst>
+                                    <p:set>
+                                      <p:cBhvr>
+                                        <p:cTn id="22" dur="1" fill="hold">
+                                          <p:stCondLst>
+                                            <p:cond delay="0"/>
+                                          </p:stCondLst>
+                                        </p:cTn>
+                                        <p:tgtEl>
+                                          <p:spTgt spid="9"/>
+                                        </p:tgtEl>
+                                        <p:attrNameLst>
+                                          <p:attrName>style.visibility</p:attrName>
+                                        </p:attrNameLst>
+                                      </p:cBhvr>
+                                      <p:to>
+                                        <p:strVal val="visible"/>
+                                      </p:to>
+                                    </p:set>
+                                    <p:animEffect transition="in" filter="fade">
+                                      <p:cBhvr>
+                                        <p:cTn id="23" dur="500"/>
+                                        <p:tgtEl>
+                                          <p:spTgt spid="9"/>
+                                        </p:tgtEl>
+                                      </p:cBhvr>
+                                    </p:animEffect>
+                                  </p:childTnLst>
+                                </p:cTn>
+                              </p:par>
+                            </p:childTnLst>
+                          </p:cTn>
+                        </p:par>
+                      </p:childTnLst>
+                    </p:cTn>
+                  </p:par>
+                </p:childTnLst>
+              </p:cTn>
+              <p:prevCondLst>
+                <p:cond evt="onPrev" delay="0">
+                  <p:tgtEl>
+                    <p:sldTgt/>
+                  </p:tgtEl>
+                </p:cond>
+              </p:prevCondLst>
+              <p:nextCondLst>
+                <p:cond evt="onNext" delay="0">
+                  <p:tgtEl>
+                    <p:sldTgt/>
+                  </p:tgtEl>
+                </p:cond>
+              </p:nextCondLst>
+            </p:seq>
+          </p:childTnLst>
+        </p:cTn>
+      </p:par>
+    </p:tnLst>
+    <p:bldLst>
+      <p:bldP spid="7" grpId="0" animBg="1"/>
+      <p:bldP spid="5" grpId="0" animBg="1"/>
+      <p:bldP spid="6" grpId="0" animBg="1"/>
+      <p:bldP spid="8" grpId="0" animBg="1"/>
+      <p:bldP spid="9" grpId="0" animBg="1"/>
+    </p:bldLst>
+  </p:timing>
 </p:sld>
 </file>
 
@@ -2674,6 +3171,13 @@
             <a:prstDash val="solid"/>
           </a:ln>
         </p:spPr>
+        <p:txBody>
+          <a:bodyPr/>
+          <a:lstStyle/>
+          <a:p>
+            <a:endParaRPr lang="es-CO"/>
+          </a:p>
+        </p:txBody>
       </p:sp>
       <p:sp>
         <p:nvSpPr>
@@ -2699,6 +3203,13 @@
             <a:prstDash val="solid"/>
           </a:ln>
         </p:spPr>
+        <p:txBody>
+          <a:bodyPr/>
+          <a:lstStyle/>
+          <a:p>
+            <a:endParaRPr lang="es-CO"/>
+          </a:p>
+        </p:txBody>
       </p:sp>
       <p:sp>
         <p:nvSpPr>
@@ -2770,6 +3281,13 @@
             </a:outerShdw>
           </a:effectLst>
         </p:spPr>
+        <p:txBody>
+          <a:bodyPr/>
+          <a:lstStyle/>
+          <a:p>
+            <a:endParaRPr lang="es-CO"/>
+          </a:p>
+        </p:txBody>
       </p:sp>
       <p:sp>
         <p:nvSpPr>
@@ -2841,6 +3359,13 @@
             </a:outerShdw>
           </a:effectLst>
         </p:spPr>
+        <p:txBody>
+          <a:bodyPr/>
+          <a:lstStyle/>
+          <a:p>
+            <a:endParaRPr lang="es-CO"/>
+          </a:p>
+        </p:txBody>
       </p:sp>
       <p:sp>
         <p:nvSpPr>
@@ -2866,6 +3391,13 @@
             <a:prstDash val="solid"/>
           </a:ln>
         </p:spPr>
+        <p:txBody>
+          <a:bodyPr/>
+          <a:lstStyle/>
+          <a:p>
+            <a:endParaRPr lang="es-CO"/>
+          </a:p>
+        </p:txBody>
       </p:sp>
       <p:sp>
         <p:nvSpPr>
@@ -2993,6 +3525,13 @@
             </a:outerShdw>
           </a:effectLst>
         </p:spPr>
+        <p:txBody>
+          <a:bodyPr/>
+          <a:lstStyle/>
+          <a:p>
+            <a:endParaRPr lang="es-CO"/>
+          </a:p>
+        </p:txBody>
       </p:sp>
       <p:sp>
         <p:nvSpPr>
@@ -3018,6 +3557,13 @@
             <a:prstDash val="solid"/>
           </a:ln>
         </p:spPr>
+        <p:txBody>
+          <a:bodyPr/>
+          <a:lstStyle/>
+          <a:p>
+            <a:endParaRPr lang="es-CO"/>
+          </a:p>
+        </p:txBody>
       </p:sp>
       <p:sp>
         <p:nvSpPr>
@@ -3145,6 +3691,13 @@
             </a:outerShdw>
           </a:effectLst>
         </p:spPr>
+        <p:txBody>
+          <a:bodyPr/>
+          <a:lstStyle/>
+          <a:p>
+            <a:endParaRPr lang="es-CO"/>
+          </a:p>
+        </p:txBody>
       </p:sp>
       <p:sp>
         <p:nvSpPr>
@@ -3170,6 +3723,13 @@
             <a:prstDash val="solid"/>
           </a:ln>
         </p:spPr>
+        <p:txBody>
+          <a:bodyPr/>
+          <a:lstStyle/>
+          <a:p>
+            <a:endParaRPr lang="es-CO"/>
+          </a:p>
+        </p:txBody>
       </p:sp>
       <p:sp>
         <p:nvSpPr>
@@ -3290,6 +3850,13 @@
             <a:prstDash val="solid"/>
           </a:ln>
         </p:spPr>
+        <p:txBody>
+          <a:bodyPr/>
+          <a:lstStyle/>
+          <a:p>
+            <a:endParaRPr lang="es-CO"/>
+          </a:p>
+        </p:txBody>
       </p:sp>
       <p:sp>
         <p:nvSpPr>
@@ -3374,6 +3941,1234 @@
   <p:clrMapOvr>
     <a:masterClrMapping/>
   </p:clrMapOvr>
+  <p:transition spd="slow">
+    <p:push dir="u"/>
+  </p:transition>
+  <p:timing>
+    <p:tnLst>
+      <p:par>
+        <p:cTn id="1" dur="indefinite" restart="never" nodeType="tmRoot">
+          <p:childTnLst>
+            <p:seq concurrent="1" nextAc="seek">
+              <p:cTn id="2" dur="indefinite" nodeType="mainSeq">
+                <p:childTnLst>
+                  <p:par>
+                    <p:cTn id="3" fill="hold">
+                      <p:stCondLst>
+                        <p:cond delay="indefinite"/>
+                      </p:stCondLst>
+                      <p:childTnLst>
+                        <p:par>
+                          <p:cTn id="4" fill="hold">
+                            <p:stCondLst>
+                              <p:cond delay="0"/>
+                            </p:stCondLst>
+                            <p:childTnLst>
+                              <p:par>
+                                <p:cTn id="5" presetID="42" presetClass="entr" presetSubtype="0" fill="hold" grpId="0" nodeType="clickEffect">
+                                  <p:stCondLst>
+                                    <p:cond delay="0"/>
+                                  </p:stCondLst>
+                                  <p:childTnLst>
+                                    <p:set>
+                                      <p:cBhvr>
+                                        <p:cTn id="6" dur="1" fill="hold">
+                                          <p:stCondLst>
+                                            <p:cond delay="0"/>
+                                          </p:stCondLst>
+                                        </p:cTn>
+                                        <p:tgtEl>
+                                          <p:spTgt spid="4"/>
+                                        </p:tgtEl>
+                                        <p:attrNameLst>
+                                          <p:attrName>style.visibility</p:attrName>
+                                        </p:attrNameLst>
+                                      </p:cBhvr>
+                                      <p:to>
+                                        <p:strVal val="visible"/>
+                                      </p:to>
+                                    </p:set>
+                                    <p:animEffect transition="in" filter="fade">
+                                      <p:cBhvr>
+                                        <p:cTn id="7" dur="500"/>
+                                        <p:tgtEl>
+                                          <p:spTgt spid="4"/>
+                                        </p:tgtEl>
+                                      </p:cBhvr>
+                                    </p:animEffect>
+                                    <p:anim calcmode="lin" valueType="num">
+                                      <p:cBhvr>
+                                        <p:cTn id="8" dur="500" fill="hold"/>
+                                        <p:tgtEl>
+                                          <p:spTgt spid="4"/>
+                                        </p:tgtEl>
+                                        <p:attrNameLst>
+                                          <p:attrName>ppt_x</p:attrName>
+                                        </p:attrNameLst>
+                                      </p:cBhvr>
+                                      <p:tavLst>
+                                        <p:tav tm="0">
+                                          <p:val>
+                                            <p:strVal val="#ppt_x"/>
+                                          </p:val>
+                                        </p:tav>
+                                        <p:tav tm="100000">
+                                          <p:val>
+                                            <p:strVal val="#ppt_x"/>
+                                          </p:val>
+                                        </p:tav>
+                                      </p:tavLst>
+                                    </p:anim>
+                                    <p:anim calcmode="lin" valueType="num">
+                                      <p:cBhvr>
+                                        <p:cTn id="9" dur="500" fill="hold"/>
+                                        <p:tgtEl>
+                                          <p:spTgt spid="4"/>
+                                        </p:tgtEl>
+                                        <p:attrNameLst>
+                                          <p:attrName>ppt_y</p:attrName>
+                                        </p:attrNameLst>
+                                      </p:cBhvr>
+                                      <p:tavLst>
+                                        <p:tav tm="0">
+                                          <p:val>
+                                            <p:strVal val="#ppt_y+.1"/>
+                                          </p:val>
+                                        </p:tav>
+                                        <p:tav tm="100000">
+                                          <p:val>
+                                            <p:strVal val="#ppt_y"/>
+                                          </p:val>
+                                        </p:tav>
+                                      </p:tavLst>
+                                    </p:anim>
+                                  </p:childTnLst>
+                                </p:cTn>
+                              </p:par>
+                            </p:childTnLst>
+                          </p:cTn>
+                        </p:par>
+                      </p:childTnLst>
+                    </p:cTn>
+                  </p:par>
+                  <p:par>
+                    <p:cTn id="10" fill="hold">
+                      <p:stCondLst>
+                        <p:cond delay="indefinite"/>
+                      </p:stCondLst>
+                      <p:childTnLst>
+                        <p:par>
+                          <p:cTn id="11" fill="hold">
+                            <p:stCondLst>
+                              <p:cond delay="0"/>
+                            </p:stCondLst>
+                            <p:childTnLst>
+                              <p:par>
+                                <p:cTn id="12" presetID="1" presetClass="entr" presetSubtype="0" fill="hold" grpId="0" nodeType="clickEffect">
+                                  <p:stCondLst>
+                                    <p:cond delay="0"/>
+                                  </p:stCondLst>
+                                  <p:childTnLst>
+                                    <p:set>
+                                      <p:cBhvr>
+                                        <p:cTn id="13" dur="1" fill="hold">
+                                          <p:stCondLst>
+                                            <p:cond delay="0"/>
+                                          </p:stCondLst>
+                                        </p:cTn>
+                                        <p:tgtEl>
+                                          <p:spTgt spid="5"/>
+                                        </p:tgtEl>
+                                        <p:attrNameLst>
+                                          <p:attrName>style.visibility</p:attrName>
+                                        </p:attrNameLst>
+                                      </p:cBhvr>
+                                      <p:to>
+                                        <p:strVal val="visible"/>
+                                      </p:to>
+                                    </p:set>
+                                  </p:childTnLst>
+                                </p:cTn>
+                              </p:par>
+                              <p:par>
+                                <p:cTn id="14" presetID="10" presetClass="entr" presetSubtype="0" fill="hold" grpId="0" nodeType="withEffect">
+                                  <p:stCondLst>
+                                    <p:cond delay="0"/>
+                                  </p:stCondLst>
+                                  <p:childTnLst>
+                                    <p:set>
+                                      <p:cBhvr>
+                                        <p:cTn id="15" dur="1" fill="hold">
+                                          <p:stCondLst>
+                                            <p:cond delay="0"/>
+                                          </p:stCondLst>
+                                        </p:cTn>
+                                        <p:tgtEl>
+                                          <p:spTgt spid="6"/>
+                                        </p:tgtEl>
+                                        <p:attrNameLst>
+                                          <p:attrName>style.visibility</p:attrName>
+                                        </p:attrNameLst>
+                                      </p:cBhvr>
+                                      <p:to>
+                                        <p:strVal val="visible"/>
+                                      </p:to>
+                                    </p:set>
+                                    <p:animEffect transition="in" filter="fade">
+                                      <p:cBhvr>
+                                        <p:cTn id="16" dur="500"/>
+                                        <p:tgtEl>
+                                          <p:spTgt spid="6"/>
+                                        </p:tgtEl>
+                                      </p:cBhvr>
+                                    </p:animEffect>
+                                  </p:childTnLst>
+                                </p:cTn>
+                              </p:par>
+                            </p:childTnLst>
+                          </p:cTn>
+                        </p:par>
+                        <p:par>
+                          <p:cTn id="17" fill="hold">
+                            <p:stCondLst>
+                              <p:cond delay="500"/>
+                            </p:stCondLst>
+                            <p:childTnLst>
+                              <p:par>
+                                <p:cTn id="18" presetID="42" presetClass="entr" presetSubtype="0" fill="hold" grpId="0" nodeType="afterEffect">
+                                  <p:stCondLst>
+                                    <p:cond delay="0"/>
+                                  </p:stCondLst>
+                                  <p:childTnLst>
+                                    <p:set>
+                                      <p:cBhvr>
+                                        <p:cTn id="19" dur="1" fill="hold">
+                                          <p:stCondLst>
+                                            <p:cond delay="0"/>
+                                          </p:stCondLst>
+                                        </p:cTn>
+                                        <p:tgtEl>
+                                          <p:spTgt spid="7"/>
+                                        </p:tgtEl>
+                                        <p:attrNameLst>
+                                          <p:attrName>style.visibility</p:attrName>
+                                        </p:attrNameLst>
+                                      </p:cBhvr>
+                                      <p:to>
+                                        <p:strVal val="visible"/>
+                                      </p:to>
+                                    </p:set>
+                                    <p:animEffect transition="in" filter="fade">
+                                      <p:cBhvr>
+                                        <p:cTn id="20" dur="1000"/>
+                                        <p:tgtEl>
+                                          <p:spTgt spid="7"/>
+                                        </p:tgtEl>
+                                      </p:cBhvr>
+                                    </p:animEffect>
+                                    <p:anim calcmode="lin" valueType="num">
+                                      <p:cBhvr>
+                                        <p:cTn id="21" dur="1000" fill="hold"/>
+                                        <p:tgtEl>
+                                          <p:spTgt spid="7"/>
+                                        </p:tgtEl>
+                                        <p:attrNameLst>
+                                          <p:attrName>ppt_x</p:attrName>
+                                        </p:attrNameLst>
+                                      </p:cBhvr>
+                                      <p:tavLst>
+                                        <p:tav tm="0">
+                                          <p:val>
+                                            <p:strVal val="#ppt_x"/>
+                                          </p:val>
+                                        </p:tav>
+                                        <p:tav tm="100000">
+                                          <p:val>
+                                            <p:strVal val="#ppt_x"/>
+                                          </p:val>
+                                        </p:tav>
+                                      </p:tavLst>
+                                    </p:anim>
+                                    <p:anim calcmode="lin" valueType="num">
+                                      <p:cBhvr>
+                                        <p:cTn id="22" dur="1000" fill="hold"/>
+                                        <p:tgtEl>
+                                          <p:spTgt spid="7"/>
+                                        </p:tgtEl>
+                                        <p:attrNameLst>
+                                          <p:attrName>ppt_y</p:attrName>
+                                        </p:attrNameLst>
+                                      </p:cBhvr>
+                                      <p:tavLst>
+                                        <p:tav tm="0">
+                                          <p:val>
+                                            <p:strVal val="#ppt_y+.1"/>
+                                          </p:val>
+                                        </p:tav>
+                                        <p:tav tm="100000">
+                                          <p:val>
+                                            <p:strVal val="#ppt_y"/>
+                                          </p:val>
+                                        </p:tav>
+                                      </p:tavLst>
+                                    </p:anim>
+                                  </p:childTnLst>
+                                </p:cTn>
+                              </p:par>
+                              <p:par>
+                                <p:cTn id="23" presetID="42" presetClass="entr" presetSubtype="0" fill="hold" grpId="0" nodeType="withEffect">
+                                  <p:stCondLst>
+                                    <p:cond delay="0"/>
+                                  </p:stCondLst>
+                                  <p:childTnLst>
+                                    <p:set>
+                                      <p:cBhvr>
+                                        <p:cTn id="24" dur="1" fill="hold">
+                                          <p:stCondLst>
+                                            <p:cond delay="0"/>
+                                          </p:stCondLst>
+                                        </p:cTn>
+                                        <p:tgtEl>
+                                          <p:spTgt spid="8"/>
+                                        </p:tgtEl>
+                                        <p:attrNameLst>
+                                          <p:attrName>style.visibility</p:attrName>
+                                        </p:attrNameLst>
+                                      </p:cBhvr>
+                                      <p:to>
+                                        <p:strVal val="visible"/>
+                                      </p:to>
+                                    </p:set>
+                                    <p:animEffect transition="in" filter="fade">
+                                      <p:cBhvr>
+                                        <p:cTn id="25" dur="1000"/>
+                                        <p:tgtEl>
+                                          <p:spTgt spid="8"/>
+                                        </p:tgtEl>
+                                      </p:cBhvr>
+                                    </p:animEffect>
+                                    <p:anim calcmode="lin" valueType="num">
+                                      <p:cBhvr>
+                                        <p:cTn id="26" dur="1000" fill="hold"/>
+                                        <p:tgtEl>
+                                          <p:spTgt spid="8"/>
+                                        </p:tgtEl>
+                                        <p:attrNameLst>
+                                          <p:attrName>ppt_x</p:attrName>
+                                        </p:attrNameLst>
+                                      </p:cBhvr>
+                                      <p:tavLst>
+                                        <p:tav tm="0">
+                                          <p:val>
+                                            <p:strVal val="#ppt_x"/>
+                                          </p:val>
+                                        </p:tav>
+                                        <p:tav tm="100000">
+                                          <p:val>
+                                            <p:strVal val="#ppt_x"/>
+                                          </p:val>
+                                        </p:tav>
+                                      </p:tavLst>
+                                    </p:anim>
+                                    <p:anim calcmode="lin" valueType="num">
+                                      <p:cBhvr>
+                                        <p:cTn id="27" dur="1000" fill="hold"/>
+                                        <p:tgtEl>
+                                          <p:spTgt spid="8"/>
+                                        </p:tgtEl>
+                                        <p:attrNameLst>
+                                          <p:attrName>ppt_y</p:attrName>
+                                        </p:attrNameLst>
+                                      </p:cBhvr>
+                                      <p:tavLst>
+                                        <p:tav tm="0">
+                                          <p:val>
+                                            <p:strVal val="#ppt_y+.1"/>
+                                          </p:val>
+                                        </p:tav>
+                                        <p:tav tm="100000">
+                                          <p:val>
+                                            <p:strVal val="#ppt_y"/>
+                                          </p:val>
+                                        </p:tav>
+                                      </p:tavLst>
+                                    </p:anim>
+                                  </p:childTnLst>
+                                </p:cTn>
+                              </p:par>
+                              <p:par>
+                                <p:cTn id="28" presetID="42" presetClass="entr" presetSubtype="0" fill="hold" grpId="0" nodeType="withEffect">
+                                  <p:stCondLst>
+                                    <p:cond delay="0"/>
+                                  </p:stCondLst>
+                                  <p:childTnLst>
+                                    <p:set>
+                                      <p:cBhvr>
+                                        <p:cTn id="29" dur="1" fill="hold">
+                                          <p:stCondLst>
+                                            <p:cond delay="0"/>
+                                          </p:stCondLst>
+                                        </p:cTn>
+                                        <p:tgtEl>
+                                          <p:spTgt spid="9"/>
+                                        </p:tgtEl>
+                                        <p:attrNameLst>
+                                          <p:attrName>style.visibility</p:attrName>
+                                        </p:attrNameLst>
+                                      </p:cBhvr>
+                                      <p:to>
+                                        <p:strVal val="visible"/>
+                                      </p:to>
+                                    </p:set>
+                                    <p:animEffect transition="in" filter="fade">
+                                      <p:cBhvr>
+                                        <p:cTn id="30" dur="1000"/>
+                                        <p:tgtEl>
+                                          <p:spTgt spid="9"/>
+                                        </p:tgtEl>
+                                      </p:cBhvr>
+                                    </p:animEffect>
+                                    <p:anim calcmode="lin" valueType="num">
+                                      <p:cBhvr>
+                                        <p:cTn id="31" dur="1000" fill="hold"/>
+                                        <p:tgtEl>
+                                          <p:spTgt spid="9"/>
+                                        </p:tgtEl>
+                                        <p:attrNameLst>
+                                          <p:attrName>ppt_x</p:attrName>
+                                        </p:attrNameLst>
+                                      </p:cBhvr>
+                                      <p:tavLst>
+                                        <p:tav tm="0">
+                                          <p:val>
+                                            <p:strVal val="#ppt_x"/>
+                                          </p:val>
+                                        </p:tav>
+                                        <p:tav tm="100000">
+                                          <p:val>
+                                            <p:strVal val="#ppt_x"/>
+                                          </p:val>
+                                        </p:tav>
+                                      </p:tavLst>
+                                    </p:anim>
+                                    <p:anim calcmode="lin" valueType="num">
+                                      <p:cBhvr>
+                                        <p:cTn id="32" dur="1000" fill="hold"/>
+                                        <p:tgtEl>
+                                          <p:spTgt spid="9"/>
+                                        </p:tgtEl>
+                                        <p:attrNameLst>
+                                          <p:attrName>ppt_y</p:attrName>
+                                        </p:attrNameLst>
+                                      </p:cBhvr>
+                                      <p:tavLst>
+                                        <p:tav tm="0">
+                                          <p:val>
+                                            <p:strVal val="#ppt_y+.1"/>
+                                          </p:val>
+                                        </p:tav>
+                                        <p:tav tm="100000">
+                                          <p:val>
+                                            <p:strVal val="#ppt_y"/>
+                                          </p:val>
+                                        </p:tav>
+                                      </p:tavLst>
+                                    </p:anim>
+                                  </p:childTnLst>
+                                </p:cTn>
+                              </p:par>
+                              <p:par>
+                                <p:cTn id="33" presetID="42" presetClass="entr" presetSubtype="0" fill="hold" grpId="0" nodeType="withEffect">
+                                  <p:stCondLst>
+                                    <p:cond delay="0"/>
+                                  </p:stCondLst>
+                                  <p:childTnLst>
+                                    <p:set>
+                                      <p:cBhvr>
+                                        <p:cTn id="34" dur="1" fill="hold">
+                                          <p:stCondLst>
+                                            <p:cond delay="0"/>
+                                          </p:stCondLst>
+                                        </p:cTn>
+                                        <p:tgtEl>
+                                          <p:spTgt spid="10"/>
+                                        </p:tgtEl>
+                                        <p:attrNameLst>
+                                          <p:attrName>style.visibility</p:attrName>
+                                        </p:attrNameLst>
+                                      </p:cBhvr>
+                                      <p:to>
+                                        <p:strVal val="visible"/>
+                                      </p:to>
+                                    </p:set>
+                                    <p:animEffect transition="in" filter="fade">
+                                      <p:cBhvr>
+                                        <p:cTn id="35" dur="1000"/>
+                                        <p:tgtEl>
+                                          <p:spTgt spid="10"/>
+                                        </p:tgtEl>
+                                      </p:cBhvr>
+                                    </p:animEffect>
+                                    <p:anim calcmode="lin" valueType="num">
+                                      <p:cBhvr>
+                                        <p:cTn id="36" dur="1000" fill="hold"/>
+                                        <p:tgtEl>
+                                          <p:spTgt spid="10"/>
+                                        </p:tgtEl>
+                                        <p:attrNameLst>
+                                          <p:attrName>ppt_x</p:attrName>
+                                        </p:attrNameLst>
+                                      </p:cBhvr>
+                                      <p:tavLst>
+                                        <p:tav tm="0">
+                                          <p:val>
+                                            <p:strVal val="#ppt_x"/>
+                                          </p:val>
+                                        </p:tav>
+                                        <p:tav tm="100000">
+                                          <p:val>
+                                            <p:strVal val="#ppt_x"/>
+                                          </p:val>
+                                        </p:tav>
+                                      </p:tavLst>
+                                    </p:anim>
+                                    <p:anim calcmode="lin" valueType="num">
+                                      <p:cBhvr>
+                                        <p:cTn id="37" dur="1000" fill="hold"/>
+                                        <p:tgtEl>
+                                          <p:spTgt spid="10"/>
+                                        </p:tgtEl>
+                                        <p:attrNameLst>
+                                          <p:attrName>ppt_y</p:attrName>
+                                        </p:attrNameLst>
+                                      </p:cBhvr>
+                                      <p:tavLst>
+                                        <p:tav tm="0">
+                                          <p:val>
+                                            <p:strVal val="#ppt_y+.1"/>
+                                          </p:val>
+                                        </p:tav>
+                                        <p:tav tm="100000">
+                                          <p:val>
+                                            <p:strVal val="#ppt_y"/>
+                                          </p:val>
+                                        </p:tav>
+                                      </p:tavLst>
+                                    </p:anim>
+                                  </p:childTnLst>
+                                </p:cTn>
+                              </p:par>
+                            </p:childTnLst>
+                          </p:cTn>
+                        </p:par>
+                        <p:par>
+                          <p:cTn id="38" fill="hold">
+                            <p:stCondLst>
+                              <p:cond delay="1500"/>
+                            </p:stCondLst>
+                            <p:childTnLst>
+                              <p:par>
+                                <p:cTn id="39" presetID="42" presetClass="entr" presetSubtype="0" fill="hold" grpId="0" nodeType="afterEffect">
+                                  <p:stCondLst>
+                                    <p:cond delay="0"/>
+                                  </p:stCondLst>
+                                  <p:childTnLst>
+                                    <p:set>
+                                      <p:cBhvr>
+                                        <p:cTn id="40" dur="1" fill="hold">
+                                          <p:stCondLst>
+                                            <p:cond delay="0"/>
+                                          </p:stCondLst>
+                                        </p:cTn>
+                                        <p:tgtEl>
+                                          <p:spTgt spid="11"/>
+                                        </p:tgtEl>
+                                        <p:attrNameLst>
+                                          <p:attrName>style.visibility</p:attrName>
+                                        </p:attrNameLst>
+                                      </p:cBhvr>
+                                      <p:to>
+                                        <p:strVal val="visible"/>
+                                      </p:to>
+                                    </p:set>
+                                    <p:animEffect transition="in" filter="fade">
+                                      <p:cBhvr>
+                                        <p:cTn id="41" dur="1000"/>
+                                        <p:tgtEl>
+                                          <p:spTgt spid="11"/>
+                                        </p:tgtEl>
+                                      </p:cBhvr>
+                                    </p:animEffect>
+                                    <p:anim calcmode="lin" valueType="num">
+                                      <p:cBhvr>
+                                        <p:cTn id="42" dur="1000" fill="hold"/>
+                                        <p:tgtEl>
+                                          <p:spTgt spid="11"/>
+                                        </p:tgtEl>
+                                        <p:attrNameLst>
+                                          <p:attrName>ppt_x</p:attrName>
+                                        </p:attrNameLst>
+                                      </p:cBhvr>
+                                      <p:tavLst>
+                                        <p:tav tm="0">
+                                          <p:val>
+                                            <p:strVal val="#ppt_x"/>
+                                          </p:val>
+                                        </p:tav>
+                                        <p:tav tm="100000">
+                                          <p:val>
+                                            <p:strVal val="#ppt_x"/>
+                                          </p:val>
+                                        </p:tav>
+                                      </p:tavLst>
+                                    </p:anim>
+                                    <p:anim calcmode="lin" valueType="num">
+                                      <p:cBhvr>
+                                        <p:cTn id="43" dur="1000" fill="hold"/>
+                                        <p:tgtEl>
+                                          <p:spTgt spid="11"/>
+                                        </p:tgtEl>
+                                        <p:attrNameLst>
+                                          <p:attrName>ppt_y</p:attrName>
+                                        </p:attrNameLst>
+                                      </p:cBhvr>
+                                      <p:tavLst>
+                                        <p:tav tm="0">
+                                          <p:val>
+                                            <p:strVal val="#ppt_y+.1"/>
+                                          </p:val>
+                                        </p:tav>
+                                        <p:tav tm="100000">
+                                          <p:val>
+                                            <p:strVal val="#ppt_y"/>
+                                          </p:val>
+                                        </p:tav>
+                                      </p:tavLst>
+                                    </p:anim>
+                                  </p:childTnLst>
+                                </p:cTn>
+                              </p:par>
+                              <p:par>
+                                <p:cTn id="44" presetID="42" presetClass="entr" presetSubtype="0" fill="hold" grpId="0" nodeType="withEffect">
+                                  <p:stCondLst>
+                                    <p:cond delay="0"/>
+                                  </p:stCondLst>
+                                  <p:childTnLst>
+                                    <p:set>
+                                      <p:cBhvr>
+                                        <p:cTn id="45" dur="1" fill="hold">
+                                          <p:stCondLst>
+                                            <p:cond delay="0"/>
+                                          </p:stCondLst>
+                                        </p:cTn>
+                                        <p:tgtEl>
+                                          <p:spTgt spid="12"/>
+                                        </p:tgtEl>
+                                        <p:attrNameLst>
+                                          <p:attrName>style.visibility</p:attrName>
+                                        </p:attrNameLst>
+                                      </p:cBhvr>
+                                      <p:to>
+                                        <p:strVal val="visible"/>
+                                      </p:to>
+                                    </p:set>
+                                    <p:animEffect transition="in" filter="fade">
+                                      <p:cBhvr>
+                                        <p:cTn id="46" dur="1000"/>
+                                        <p:tgtEl>
+                                          <p:spTgt spid="12"/>
+                                        </p:tgtEl>
+                                      </p:cBhvr>
+                                    </p:animEffect>
+                                    <p:anim calcmode="lin" valueType="num">
+                                      <p:cBhvr>
+                                        <p:cTn id="47" dur="1000" fill="hold"/>
+                                        <p:tgtEl>
+                                          <p:spTgt spid="12"/>
+                                        </p:tgtEl>
+                                        <p:attrNameLst>
+                                          <p:attrName>ppt_x</p:attrName>
+                                        </p:attrNameLst>
+                                      </p:cBhvr>
+                                      <p:tavLst>
+                                        <p:tav tm="0">
+                                          <p:val>
+                                            <p:strVal val="#ppt_x"/>
+                                          </p:val>
+                                        </p:tav>
+                                        <p:tav tm="100000">
+                                          <p:val>
+                                            <p:strVal val="#ppt_x"/>
+                                          </p:val>
+                                        </p:tav>
+                                      </p:tavLst>
+                                    </p:anim>
+                                    <p:anim calcmode="lin" valueType="num">
+                                      <p:cBhvr>
+                                        <p:cTn id="48" dur="1000" fill="hold"/>
+                                        <p:tgtEl>
+                                          <p:spTgt spid="12"/>
+                                        </p:tgtEl>
+                                        <p:attrNameLst>
+                                          <p:attrName>ppt_y</p:attrName>
+                                        </p:attrNameLst>
+                                      </p:cBhvr>
+                                      <p:tavLst>
+                                        <p:tav tm="0">
+                                          <p:val>
+                                            <p:strVal val="#ppt_y+.1"/>
+                                          </p:val>
+                                        </p:tav>
+                                        <p:tav tm="100000">
+                                          <p:val>
+                                            <p:strVal val="#ppt_y"/>
+                                          </p:val>
+                                        </p:tav>
+                                      </p:tavLst>
+                                    </p:anim>
+                                  </p:childTnLst>
+                                </p:cTn>
+                              </p:par>
+                              <p:par>
+                                <p:cTn id="49" presetID="42" presetClass="entr" presetSubtype="0" fill="hold" grpId="0" nodeType="withEffect">
+                                  <p:stCondLst>
+                                    <p:cond delay="0"/>
+                                  </p:stCondLst>
+                                  <p:childTnLst>
+                                    <p:set>
+                                      <p:cBhvr>
+                                        <p:cTn id="50" dur="1" fill="hold">
+                                          <p:stCondLst>
+                                            <p:cond delay="0"/>
+                                          </p:stCondLst>
+                                        </p:cTn>
+                                        <p:tgtEl>
+                                          <p:spTgt spid="13"/>
+                                        </p:tgtEl>
+                                        <p:attrNameLst>
+                                          <p:attrName>style.visibility</p:attrName>
+                                        </p:attrNameLst>
+                                      </p:cBhvr>
+                                      <p:to>
+                                        <p:strVal val="visible"/>
+                                      </p:to>
+                                    </p:set>
+                                    <p:animEffect transition="in" filter="fade">
+                                      <p:cBhvr>
+                                        <p:cTn id="51" dur="1000"/>
+                                        <p:tgtEl>
+                                          <p:spTgt spid="13"/>
+                                        </p:tgtEl>
+                                      </p:cBhvr>
+                                    </p:animEffect>
+                                    <p:anim calcmode="lin" valueType="num">
+                                      <p:cBhvr>
+                                        <p:cTn id="52" dur="1000" fill="hold"/>
+                                        <p:tgtEl>
+                                          <p:spTgt spid="13"/>
+                                        </p:tgtEl>
+                                        <p:attrNameLst>
+                                          <p:attrName>ppt_x</p:attrName>
+                                        </p:attrNameLst>
+                                      </p:cBhvr>
+                                      <p:tavLst>
+                                        <p:tav tm="0">
+                                          <p:val>
+                                            <p:strVal val="#ppt_x"/>
+                                          </p:val>
+                                        </p:tav>
+                                        <p:tav tm="100000">
+                                          <p:val>
+                                            <p:strVal val="#ppt_x"/>
+                                          </p:val>
+                                        </p:tav>
+                                      </p:tavLst>
+                                    </p:anim>
+                                    <p:anim calcmode="lin" valueType="num">
+                                      <p:cBhvr>
+                                        <p:cTn id="53" dur="1000" fill="hold"/>
+                                        <p:tgtEl>
+                                          <p:spTgt spid="13"/>
+                                        </p:tgtEl>
+                                        <p:attrNameLst>
+                                          <p:attrName>ppt_y</p:attrName>
+                                        </p:attrNameLst>
+                                      </p:cBhvr>
+                                      <p:tavLst>
+                                        <p:tav tm="0">
+                                          <p:val>
+                                            <p:strVal val="#ppt_y+.1"/>
+                                          </p:val>
+                                        </p:tav>
+                                        <p:tav tm="100000">
+                                          <p:val>
+                                            <p:strVal val="#ppt_y"/>
+                                          </p:val>
+                                        </p:tav>
+                                      </p:tavLst>
+                                    </p:anim>
+                                  </p:childTnLst>
+                                </p:cTn>
+                              </p:par>
+                              <p:par>
+                                <p:cTn id="54" presetID="42" presetClass="entr" presetSubtype="0" fill="hold" grpId="0" nodeType="withEffect">
+                                  <p:stCondLst>
+                                    <p:cond delay="0"/>
+                                  </p:stCondLst>
+                                  <p:childTnLst>
+                                    <p:set>
+                                      <p:cBhvr>
+                                        <p:cTn id="55" dur="1" fill="hold">
+                                          <p:stCondLst>
+                                            <p:cond delay="0"/>
+                                          </p:stCondLst>
+                                        </p:cTn>
+                                        <p:tgtEl>
+                                          <p:spTgt spid="14"/>
+                                        </p:tgtEl>
+                                        <p:attrNameLst>
+                                          <p:attrName>style.visibility</p:attrName>
+                                        </p:attrNameLst>
+                                      </p:cBhvr>
+                                      <p:to>
+                                        <p:strVal val="visible"/>
+                                      </p:to>
+                                    </p:set>
+                                    <p:animEffect transition="in" filter="fade">
+                                      <p:cBhvr>
+                                        <p:cTn id="56" dur="1000"/>
+                                        <p:tgtEl>
+                                          <p:spTgt spid="14"/>
+                                        </p:tgtEl>
+                                      </p:cBhvr>
+                                    </p:animEffect>
+                                    <p:anim calcmode="lin" valueType="num">
+                                      <p:cBhvr>
+                                        <p:cTn id="57" dur="1000" fill="hold"/>
+                                        <p:tgtEl>
+                                          <p:spTgt spid="14"/>
+                                        </p:tgtEl>
+                                        <p:attrNameLst>
+                                          <p:attrName>ppt_x</p:attrName>
+                                        </p:attrNameLst>
+                                      </p:cBhvr>
+                                      <p:tavLst>
+                                        <p:tav tm="0">
+                                          <p:val>
+                                            <p:strVal val="#ppt_x"/>
+                                          </p:val>
+                                        </p:tav>
+                                        <p:tav tm="100000">
+                                          <p:val>
+                                            <p:strVal val="#ppt_x"/>
+                                          </p:val>
+                                        </p:tav>
+                                      </p:tavLst>
+                                    </p:anim>
+                                    <p:anim calcmode="lin" valueType="num">
+                                      <p:cBhvr>
+                                        <p:cTn id="58" dur="1000" fill="hold"/>
+                                        <p:tgtEl>
+                                          <p:spTgt spid="14"/>
+                                        </p:tgtEl>
+                                        <p:attrNameLst>
+                                          <p:attrName>ppt_y</p:attrName>
+                                        </p:attrNameLst>
+                                      </p:cBhvr>
+                                      <p:tavLst>
+                                        <p:tav tm="0">
+                                          <p:val>
+                                            <p:strVal val="#ppt_y+.1"/>
+                                          </p:val>
+                                        </p:tav>
+                                        <p:tav tm="100000">
+                                          <p:val>
+                                            <p:strVal val="#ppt_y"/>
+                                          </p:val>
+                                        </p:tav>
+                                      </p:tavLst>
+                                    </p:anim>
+                                  </p:childTnLst>
+                                </p:cTn>
+                              </p:par>
+                            </p:childTnLst>
+                          </p:cTn>
+                        </p:par>
+                        <p:par>
+                          <p:cTn id="59" fill="hold">
+                            <p:stCondLst>
+                              <p:cond delay="2500"/>
+                            </p:stCondLst>
+                            <p:childTnLst>
+                              <p:par>
+                                <p:cTn id="60" presetID="42" presetClass="entr" presetSubtype="0" fill="hold" grpId="0" nodeType="afterEffect">
+                                  <p:stCondLst>
+                                    <p:cond delay="0"/>
+                                  </p:stCondLst>
+                                  <p:childTnLst>
+                                    <p:set>
+                                      <p:cBhvr>
+                                        <p:cTn id="61" dur="1" fill="hold">
+                                          <p:stCondLst>
+                                            <p:cond delay="0"/>
+                                          </p:stCondLst>
+                                        </p:cTn>
+                                        <p:tgtEl>
+                                          <p:spTgt spid="15"/>
+                                        </p:tgtEl>
+                                        <p:attrNameLst>
+                                          <p:attrName>style.visibility</p:attrName>
+                                        </p:attrNameLst>
+                                      </p:cBhvr>
+                                      <p:to>
+                                        <p:strVal val="visible"/>
+                                      </p:to>
+                                    </p:set>
+                                    <p:animEffect transition="in" filter="fade">
+                                      <p:cBhvr>
+                                        <p:cTn id="62" dur="1000"/>
+                                        <p:tgtEl>
+                                          <p:spTgt spid="15"/>
+                                        </p:tgtEl>
+                                      </p:cBhvr>
+                                    </p:animEffect>
+                                    <p:anim calcmode="lin" valueType="num">
+                                      <p:cBhvr>
+                                        <p:cTn id="63" dur="1000" fill="hold"/>
+                                        <p:tgtEl>
+                                          <p:spTgt spid="15"/>
+                                        </p:tgtEl>
+                                        <p:attrNameLst>
+                                          <p:attrName>ppt_x</p:attrName>
+                                        </p:attrNameLst>
+                                      </p:cBhvr>
+                                      <p:tavLst>
+                                        <p:tav tm="0">
+                                          <p:val>
+                                            <p:strVal val="#ppt_x"/>
+                                          </p:val>
+                                        </p:tav>
+                                        <p:tav tm="100000">
+                                          <p:val>
+                                            <p:strVal val="#ppt_x"/>
+                                          </p:val>
+                                        </p:tav>
+                                      </p:tavLst>
+                                    </p:anim>
+                                    <p:anim calcmode="lin" valueType="num">
+                                      <p:cBhvr>
+                                        <p:cTn id="64" dur="1000" fill="hold"/>
+                                        <p:tgtEl>
+                                          <p:spTgt spid="15"/>
+                                        </p:tgtEl>
+                                        <p:attrNameLst>
+                                          <p:attrName>ppt_y</p:attrName>
+                                        </p:attrNameLst>
+                                      </p:cBhvr>
+                                      <p:tavLst>
+                                        <p:tav tm="0">
+                                          <p:val>
+                                            <p:strVal val="#ppt_y+.1"/>
+                                          </p:val>
+                                        </p:tav>
+                                        <p:tav tm="100000">
+                                          <p:val>
+                                            <p:strVal val="#ppt_y"/>
+                                          </p:val>
+                                        </p:tav>
+                                      </p:tavLst>
+                                    </p:anim>
+                                  </p:childTnLst>
+                                </p:cTn>
+                              </p:par>
+                              <p:par>
+                                <p:cTn id="65" presetID="42" presetClass="entr" presetSubtype="0" fill="hold" grpId="0" nodeType="withEffect">
+                                  <p:stCondLst>
+                                    <p:cond delay="0"/>
+                                  </p:stCondLst>
+                                  <p:childTnLst>
+                                    <p:set>
+                                      <p:cBhvr>
+                                        <p:cTn id="66" dur="1" fill="hold">
+                                          <p:stCondLst>
+                                            <p:cond delay="0"/>
+                                          </p:stCondLst>
+                                        </p:cTn>
+                                        <p:tgtEl>
+                                          <p:spTgt spid="16"/>
+                                        </p:tgtEl>
+                                        <p:attrNameLst>
+                                          <p:attrName>style.visibility</p:attrName>
+                                        </p:attrNameLst>
+                                      </p:cBhvr>
+                                      <p:to>
+                                        <p:strVal val="visible"/>
+                                      </p:to>
+                                    </p:set>
+                                    <p:animEffect transition="in" filter="fade">
+                                      <p:cBhvr>
+                                        <p:cTn id="67" dur="1000"/>
+                                        <p:tgtEl>
+                                          <p:spTgt spid="16"/>
+                                        </p:tgtEl>
+                                      </p:cBhvr>
+                                    </p:animEffect>
+                                    <p:anim calcmode="lin" valueType="num">
+                                      <p:cBhvr>
+                                        <p:cTn id="68" dur="1000" fill="hold"/>
+                                        <p:tgtEl>
+                                          <p:spTgt spid="16"/>
+                                        </p:tgtEl>
+                                        <p:attrNameLst>
+                                          <p:attrName>ppt_x</p:attrName>
+                                        </p:attrNameLst>
+                                      </p:cBhvr>
+                                      <p:tavLst>
+                                        <p:tav tm="0">
+                                          <p:val>
+                                            <p:strVal val="#ppt_x"/>
+                                          </p:val>
+                                        </p:tav>
+                                        <p:tav tm="100000">
+                                          <p:val>
+                                            <p:strVal val="#ppt_x"/>
+                                          </p:val>
+                                        </p:tav>
+                                      </p:tavLst>
+                                    </p:anim>
+                                    <p:anim calcmode="lin" valueType="num">
+                                      <p:cBhvr>
+                                        <p:cTn id="69" dur="1000" fill="hold"/>
+                                        <p:tgtEl>
+                                          <p:spTgt spid="16"/>
+                                        </p:tgtEl>
+                                        <p:attrNameLst>
+                                          <p:attrName>ppt_y</p:attrName>
+                                        </p:attrNameLst>
+                                      </p:cBhvr>
+                                      <p:tavLst>
+                                        <p:tav tm="0">
+                                          <p:val>
+                                            <p:strVal val="#ppt_y+.1"/>
+                                          </p:val>
+                                        </p:tav>
+                                        <p:tav tm="100000">
+                                          <p:val>
+                                            <p:strVal val="#ppt_y"/>
+                                          </p:val>
+                                        </p:tav>
+                                      </p:tavLst>
+                                    </p:anim>
+                                  </p:childTnLst>
+                                </p:cTn>
+                              </p:par>
+                              <p:par>
+                                <p:cTn id="70" presetID="42" presetClass="entr" presetSubtype="0" fill="hold" grpId="0" nodeType="withEffect">
+                                  <p:stCondLst>
+                                    <p:cond delay="0"/>
+                                  </p:stCondLst>
+                                  <p:childTnLst>
+                                    <p:set>
+                                      <p:cBhvr>
+                                        <p:cTn id="71" dur="1" fill="hold">
+                                          <p:stCondLst>
+                                            <p:cond delay="0"/>
+                                          </p:stCondLst>
+                                        </p:cTn>
+                                        <p:tgtEl>
+                                          <p:spTgt spid="17"/>
+                                        </p:tgtEl>
+                                        <p:attrNameLst>
+                                          <p:attrName>style.visibility</p:attrName>
+                                        </p:attrNameLst>
+                                      </p:cBhvr>
+                                      <p:to>
+                                        <p:strVal val="visible"/>
+                                      </p:to>
+                                    </p:set>
+                                    <p:animEffect transition="in" filter="fade">
+                                      <p:cBhvr>
+                                        <p:cTn id="72" dur="1000"/>
+                                        <p:tgtEl>
+                                          <p:spTgt spid="17"/>
+                                        </p:tgtEl>
+                                      </p:cBhvr>
+                                    </p:animEffect>
+                                    <p:anim calcmode="lin" valueType="num">
+                                      <p:cBhvr>
+                                        <p:cTn id="73" dur="1000" fill="hold"/>
+                                        <p:tgtEl>
+                                          <p:spTgt spid="17"/>
+                                        </p:tgtEl>
+                                        <p:attrNameLst>
+                                          <p:attrName>ppt_x</p:attrName>
+                                        </p:attrNameLst>
+                                      </p:cBhvr>
+                                      <p:tavLst>
+                                        <p:tav tm="0">
+                                          <p:val>
+                                            <p:strVal val="#ppt_x"/>
+                                          </p:val>
+                                        </p:tav>
+                                        <p:tav tm="100000">
+                                          <p:val>
+                                            <p:strVal val="#ppt_x"/>
+                                          </p:val>
+                                        </p:tav>
+                                      </p:tavLst>
+                                    </p:anim>
+                                    <p:anim calcmode="lin" valueType="num">
+                                      <p:cBhvr>
+                                        <p:cTn id="74" dur="1000" fill="hold"/>
+                                        <p:tgtEl>
+                                          <p:spTgt spid="17"/>
+                                        </p:tgtEl>
+                                        <p:attrNameLst>
+                                          <p:attrName>ppt_y</p:attrName>
+                                        </p:attrNameLst>
+                                      </p:cBhvr>
+                                      <p:tavLst>
+                                        <p:tav tm="0">
+                                          <p:val>
+                                            <p:strVal val="#ppt_y+.1"/>
+                                          </p:val>
+                                        </p:tav>
+                                        <p:tav tm="100000">
+                                          <p:val>
+                                            <p:strVal val="#ppt_y"/>
+                                          </p:val>
+                                        </p:tav>
+                                      </p:tavLst>
+                                    </p:anim>
+                                  </p:childTnLst>
+                                </p:cTn>
+                              </p:par>
+                              <p:par>
+                                <p:cTn id="75" presetID="42" presetClass="entr" presetSubtype="0" fill="hold" grpId="0" nodeType="withEffect">
+                                  <p:stCondLst>
+                                    <p:cond delay="0"/>
+                                  </p:stCondLst>
+                                  <p:childTnLst>
+                                    <p:set>
+                                      <p:cBhvr>
+                                        <p:cTn id="76" dur="1" fill="hold">
+                                          <p:stCondLst>
+                                            <p:cond delay="0"/>
+                                          </p:stCondLst>
+                                        </p:cTn>
+                                        <p:tgtEl>
+                                          <p:spTgt spid="18"/>
+                                        </p:tgtEl>
+                                        <p:attrNameLst>
+                                          <p:attrName>style.visibility</p:attrName>
+                                        </p:attrNameLst>
+                                      </p:cBhvr>
+                                      <p:to>
+                                        <p:strVal val="visible"/>
+                                      </p:to>
+                                    </p:set>
+                                    <p:animEffect transition="in" filter="fade">
+                                      <p:cBhvr>
+                                        <p:cTn id="77" dur="1000"/>
+                                        <p:tgtEl>
+                                          <p:spTgt spid="18"/>
+                                        </p:tgtEl>
+                                      </p:cBhvr>
+                                    </p:animEffect>
+                                    <p:anim calcmode="lin" valueType="num">
+                                      <p:cBhvr>
+                                        <p:cTn id="78" dur="1000" fill="hold"/>
+                                        <p:tgtEl>
+                                          <p:spTgt spid="18"/>
+                                        </p:tgtEl>
+                                        <p:attrNameLst>
+                                          <p:attrName>ppt_x</p:attrName>
+                                        </p:attrNameLst>
+                                      </p:cBhvr>
+                                      <p:tavLst>
+                                        <p:tav tm="0">
+                                          <p:val>
+                                            <p:strVal val="#ppt_x"/>
+                                          </p:val>
+                                        </p:tav>
+                                        <p:tav tm="100000">
+                                          <p:val>
+                                            <p:strVal val="#ppt_x"/>
+                                          </p:val>
+                                        </p:tav>
+                                      </p:tavLst>
+                                    </p:anim>
+                                    <p:anim calcmode="lin" valueType="num">
+                                      <p:cBhvr>
+                                        <p:cTn id="79" dur="1000" fill="hold"/>
+                                        <p:tgtEl>
+                                          <p:spTgt spid="18"/>
+                                        </p:tgtEl>
+                                        <p:attrNameLst>
+                                          <p:attrName>ppt_y</p:attrName>
+                                        </p:attrNameLst>
+                                      </p:cBhvr>
+                                      <p:tavLst>
+                                        <p:tav tm="0">
+                                          <p:val>
+                                            <p:strVal val="#ppt_y+.1"/>
+                                          </p:val>
+                                        </p:tav>
+                                        <p:tav tm="100000">
+                                          <p:val>
+                                            <p:strVal val="#ppt_y"/>
+                                          </p:val>
+                                        </p:tav>
+                                      </p:tavLst>
+                                    </p:anim>
+                                  </p:childTnLst>
+                                </p:cTn>
+                              </p:par>
+                            </p:childTnLst>
+                          </p:cTn>
+                        </p:par>
+                      </p:childTnLst>
+                    </p:cTn>
+                  </p:par>
+                </p:childTnLst>
+              </p:cTn>
+              <p:prevCondLst>
+                <p:cond evt="onPrev" delay="0">
+                  <p:tgtEl>
+                    <p:sldTgt/>
+                  </p:tgtEl>
+                </p:cond>
+              </p:prevCondLst>
+              <p:nextCondLst>
+                <p:cond evt="onNext" delay="0">
+                  <p:tgtEl>
+                    <p:sldTgt/>
+                  </p:tgtEl>
+                </p:cond>
+              </p:nextCondLst>
+            </p:seq>
+          </p:childTnLst>
+        </p:cTn>
+      </p:par>
+    </p:tnLst>
+    <p:bldLst>
+      <p:bldP spid="4" grpId="0" animBg="1"/>
+      <p:bldP spid="5" grpId="0" animBg="1"/>
+      <p:bldP spid="6" grpId="0" animBg="1"/>
+      <p:bldP spid="7" grpId="0" animBg="1"/>
+      <p:bldP spid="8" grpId="0" animBg="1"/>
+      <p:bldP spid="9" grpId="0" animBg="1"/>
+      <p:bldP spid="10" grpId="0" animBg="1"/>
+      <p:bldP spid="11" grpId="0" animBg="1"/>
+      <p:bldP spid="12" grpId="0" animBg="1"/>
+      <p:bldP spid="13" grpId="0" animBg="1"/>
+      <p:bldP spid="14" grpId="0" animBg="1"/>
+      <p:bldP spid="15" grpId="0" animBg="1"/>
+      <p:bldP spid="16" grpId="0" animBg="1"/>
+      <p:bldP spid="17" grpId="0" animBg="1"/>
+      <p:bldP spid="18" grpId="0" animBg="1"/>
+    </p:bldLst>
+  </p:timing>
 </p:sld>
 </file>
 
@@ -3426,6 +5221,13 @@
             <a:prstDash val="solid"/>
           </a:ln>
         </p:spPr>
+        <p:txBody>
+          <a:bodyPr/>
+          <a:lstStyle/>
+          <a:p>
+            <a:endParaRPr lang="es-CO"/>
+          </a:p>
+        </p:txBody>
       </p:sp>
       <p:sp>
         <p:nvSpPr>
@@ -3451,6 +5253,13 @@
             <a:prstDash val="solid"/>
           </a:ln>
         </p:spPr>
+        <p:txBody>
+          <a:bodyPr/>
+          <a:lstStyle/>
+          <a:p>
+            <a:endParaRPr lang="es-CO"/>
+          </a:p>
+        </p:txBody>
       </p:sp>
       <p:sp>
         <p:nvSpPr>
@@ -4175,6 +5984,13 @@
             </a:outerShdw>
           </a:effectLst>
         </p:spPr>
+        <p:txBody>
+          <a:bodyPr/>
+          <a:lstStyle/>
+          <a:p>
+            <a:endParaRPr lang="es-CO"/>
+          </a:p>
+        </p:txBody>
       </p:sp>
       <p:sp>
         <p:nvSpPr>
@@ -4200,6 +6016,13 @@
             <a:prstDash val="solid"/>
           </a:ln>
         </p:spPr>
+        <p:txBody>
+          <a:bodyPr/>
+          <a:lstStyle/>
+          <a:p>
+            <a:endParaRPr lang="es-CO"/>
+          </a:p>
+        </p:txBody>
       </p:sp>
       <p:sp>
         <p:nvSpPr>
@@ -4286,6 +6109,13 @@
             <a:prstDash val="solid"/>
           </a:ln>
         </p:spPr>
+        <p:txBody>
+          <a:bodyPr/>
+          <a:lstStyle/>
+          <a:p>
+            <a:endParaRPr lang="es-CO"/>
+          </a:p>
+        </p:txBody>
       </p:sp>
       <p:sp>
         <p:nvSpPr>
@@ -4422,6 +6252,13 @@
             <a:prstDash val="solid"/>
           </a:ln>
         </p:spPr>
+        <p:txBody>
+          <a:bodyPr/>
+          <a:lstStyle/>
+          <a:p>
+            <a:endParaRPr lang="es-CO"/>
+          </a:p>
+        </p:txBody>
       </p:sp>
       <p:sp>
         <p:nvSpPr>
@@ -4447,6 +6284,13 @@
             <a:prstDash val="solid"/>
           </a:ln>
         </p:spPr>
+        <p:txBody>
+          <a:bodyPr/>
+          <a:lstStyle/>
+          <a:p>
+            <a:endParaRPr lang="es-CO"/>
+          </a:p>
+        </p:txBody>
       </p:sp>
       <p:sp>
         <p:nvSpPr>
@@ -4511,6 +6355,13 @@
             <a:prstDash val="solid"/>
           </a:ln>
         </p:spPr>
+        <p:txBody>
+          <a:bodyPr/>
+          <a:lstStyle/>
+          <a:p>
+            <a:endParaRPr lang="es-CO"/>
+          </a:p>
+        </p:txBody>
       </p:sp>
       <p:sp>
         <p:nvSpPr>
@@ -4536,6 +6387,13 @@
             <a:prstDash val="solid"/>
           </a:ln>
         </p:spPr>
+        <p:txBody>
+          <a:bodyPr/>
+          <a:lstStyle/>
+          <a:p>
+            <a:endParaRPr lang="es-CO"/>
+          </a:p>
+        </p:txBody>
       </p:sp>
       <p:sp>
         <p:nvSpPr>
@@ -4622,6 +6480,13 @@
             <a:prstDash val="solid"/>
           </a:ln>
         </p:spPr>
+        <p:txBody>
+          <a:bodyPr/>
+          <a:lstStyle/>
+          <a:p>
+            <a:endParaRPr lang="es-CO"/>
+          </a:p>
+        </p:txBody>
       </p:sp>
       <p:sp>
         <p:nvSpPr>
@@ -4686,6 +6551,13 @@
             <a:prstDash val="solid"/>
           </a:ln>
         </p:spPr>
+        <p:txBody>
+          <a:bodyPr/>
+          <a:lstStyle/>
+          <a:p>
+            <a:endParaRPr lang="es-CO"/>
+          </a:p>
+        </p:txBody>
       </p:sp>
       <p:sp>
         <p:nvSpPr>
@@ -4767,6 +6639,13 @@
             <a:prstDash val="solid"/>
           </a:ln>
         </p:spPr>
+        <p:txBody>
+          <a:bodyPr/>
+          <a:lstStyle/>
+          <a:p>
+            <a:endParaRPr lang="es-CO"/>
+          </a:p>
+        </p:txBody>
       </p:sp>
       <p:sp>
         <p:nvSpPr>
@@ -4848,6 +6727,13 @@
             <a:prstDash val="solid"/>
           </a:ln>
         </p:spPr>
+        <p:txBody>
+          <a:bodyPr/>
+          <a:lstStyle/>
+          <a:p>
+            <a:endParaRPr lang="es-CO"/>
+          </a:p>
+        </p:txBody>
       </p:sp>
       <p:sp>
         <p:nvSpPr>
@@ -4929,6 +6815,13 @@
             <a:prstDash val="solid"/>
           </a:ln>
         </p:spPr>
+        <p:txBody>
+          <a:bodyPr/>
+          <a:lstStyle/>
+          <a:p>
+            <a:endParaRPr lang="es-CO"/>
+          </a:p>
+        </p:txBody>
       </p:sp>
       <p:sp>
         <p:nvSpPr>
@@ -4993,6 +6886,13 @@
             <a:prstDash val="solid"/>
           </a:ln>
         </p:spPr>
+        <p:txBody>
+          <a:bodyPr/>
+          <a:lstStyle/>
+          <a:p>
+            <a:endParaRPr lang="es-CO"/>
+          </a:p>
+        </p:txBody>
       </p:sp>
       <p:sp>
         <p:nvSpPr>
@@ -5091,6 +6991,13 @@
             <a:prstDash val="solid"/>
           </a:ln>
         </p:spPr>
+        <p:txBody>
+          <a:bodyPr/>
+          <a:lstStyle/>
+          <a:p>
+            <a:endParaRPr lang="es-CO"/>
+          </a:p>
+        </p:txBody>
       </p:sp>
       <p:sp>
         <p:nvSpPr>
@@ -5172,6 +7079,13 @@
             <a:prstDash val="solid"/>
           </a:ln>
         </p:spPr>
+        <p:txBody>
+          <a:bodyPr/>
+          <a:lstStyle/>
+          <a:p>
+            <a:endParaRPr lang="es-CO"/>
+          </a:p>
+        </p:txBody>
       </p:sp>
       <p:sp>
         <p:nvSpPr>
@@ -5253,6 +7167,13 @@
             <a:prstDash val="solid"/>
           </a:ln>
         </p:spPr>
+        <p:txBody>
+          <a:bodyPr/>
+          <a:lstStyle/>
+          <a:p>
+            <a:endParaRPr lang="es-CO"/>
+          </a:p>
+        </p:txBody>
       </p:sp>
       <p:sp>
         <p:nvSpPr>
@@ -5389,6 +7310,13 @@
             <a:prstDash val="solid"/>
           </a:ln>
         </p:spPr>
+        <p:txBody>
+          <a:bodyPr/>
+          <a:lstStyle/>
+          <a:p>
+            <a:endParaRPr lang="es-CO"/>
+          </a:p>
+        </p:txBody>
       </p:sp>
       <p:sp>
         <p:nvSpPr>
@@ -5414,6 +7342,13 @@
             <a:prstDash val="solid"/>
           </a:ln>
         </p:spPr>
+        <p:txBody>
+          <a:bodyPr/>
+          <a:lstStyle/>
+          <a:p>
+            <a:endParaRPr lang="es-CO"/>
+          </a:p>
+        </p:txBody>
       </p:sp>
       <p:sp>
         <p:nvSpPr>
@@ -5485,6 +7420,13 @@
             </a:outerShdw>
           </a:effectLst>
         </p:spPr>
+        <p:txBody>
+          <a:bodyPr/>
+          <a:lstStyle/>
+          <a:p>
+            <a:endParaRPr lang="es-CO"/>
+          </a:p>
+        </p:txBody>
       </p:sp>
       <p:sp>
         <p:nvSpPr>
@@ -5510,6 +7452,13 @@
             <a:prstDash val="solid"/>
           </a:ln>
         </p:spPr>
+        <p:txBody>
+          <a:bodyPr/>
+          <a:lstStyle/>
+          <a:p>
+            <a:endParaRPr lang="es-CO"/>
+          </a:p>
+        </p:txBody>
       </p:sp>
       <p:sp>
         <p:nvSpPr>
@@ -5537,6 +7486,13 @@
             <a:prstDash val="solid"/>
           </a:ln>
         </p:spPr>
+        <p:txBody>
+          <a:bodyPr/>
+          <a:lstStyle/>
+          <a:p>
+            <a:endParaRPr lang="es-CO"/>
+          </a:p>
+        </p:txBody>
       </p:sp>
       <p:sp>
         <p:nvSpPr>
@@ -5679,6 +7635,13 @@
             <a:prstDash val="solid"/>
           </a:ln>
         </p:spPr>
+        <p:txBody>
+          <a:bodyPr/>
+          <a:lstStyle/>
+          <a:p>
+            <a:endParaRPr lang="es-CO"/>
+          </a:p>
+        </p:txBody>
       </p:sp>
       <p:sp>
         <p:nvSpPr>
@@ -5750,6 +7713,13 @@
             </a:outerShdw>
           </a:effectLst>
         </p:spPr>
+        <p:txBody>
+          <a:bodyPr/>
+          <a:lstStyle/>
+          <a:p>
+            <a:endParaRPr lang="es-CO"/>
+          </a:p>
+        </p:txBody>
       </p:sp>
       <p:sp>
         <p:nvSpPr>
@@ -5775,6 +7745,13 @@
             <a:prstDash val="solid"/>
           </a:ln>
         </p:spPr>
+        <p:txBody>
+          <a:bodyPr/>
+          <a:lstStyle/>
+          <a:p>
+            <a:endParaRPr lang="es-CO"/>
+          </a:p>
+        </p:txBody>
       </p:sp>
       <p:sp>
         <p:nvSpPr>
@@ -5802,6 +7779,13 @@
             <a:prstDash val="solid"/>
           </a:ln>
         </p:spPr>
+        <p:txBody>
+          <a:bodyPr/>
+          <a:lstStyle/>
+          <a:p>
+            <a:endParaRPr lang="es-CO"/>
+          </a:p>
+        </p:txBody>
       </p:sp>
       <p:sp>
         <p:nvSpPr>
@@ -5944,6 +7928,13 @@
             <a:prstDash val="solid"/>
           </a:ln>
         </p:spPr>
+        <p:txBody>
+          <a:bodyPr/>
+          <a:lstStyle/>
+          <a:p>
+            <a:endParaRPr lang="es-CO"/>
+          </a:p>
+        </p:txBody>
       </p:sp>
       <p:sp>
         <p:nvSpPr>
@@ -6015,6 +8006,13 @@
             </a:outerShdw>
           </a:effectLst>
         </p:spPr>
+        <p:txBody>
+          <a:bodyPr/>
+          <a:lstStyle/>
+          <a:p>
+            <a:endParaRPr lang="es-CO"/>
+          </a:p>
+        </p:txBody>
       </p:sp>
       <p:sp>
         <p:nvSpPr>
@@ -6040,6 +8038,13 @@
             <a:prstDash val="solid"/>
           </a:ln>
         </p:spPr>
+        <p:txBody>
+          <a:bodyPr/>
+          <a:lstStyle/>
+          <a:p>
+            <a:endParaRPr lang="es-CO"/>
+          </a:p>
+        </p:txBody>
       </p:sp>
       <p:sp>
         <p:nvSpPr>
@@ -6067,6 +8072,13 @@
             <a:prstDash val="solid"/>
           </a:ln>
         </p:spPr>
+        <p:txBody>
+          <a:bodyPr/>
+          <a:lstStyle/>
+          <a:p>
+            <a:endParaRPr lang="es-CO"/>
+          </a:p>
+        </p:txBody>
       </p:sp>
       <p:sp>
         <p:nvSpPr>
@@ -6209,6 +8221,13 @@
             <a:prstDash val="solid"/>
           </a:ln>
         </p:spPr>
+        <p:txBody>
+          <a:bodyPr/>
+          <a:lstStyle/>
+          <a:p>
+            <a:endParaRPr lang="es-CO"/>
+          </a:p>
+        </p:txBody>
       </p:sp>
       <p:sp>
         <p:nvSpPr>
@@ -6289,6 +8308,13 @@
             <a:prstDash val="solid"/>
           </a:ln>
         </p:spPr>
+        <p:txBody>
+          <a:bodyPr/>
+          <a:lstStyle/>
+          <a:p>
+            <a:endParaRPr lang="es-CO"/>
+          </a:p>
+        </p:txBody>
       </p:sp>
       <p:sp>
         <p:nvSpPr>
@@ -6425,6 +8451,13 @@
             <a:prstDash val="solid"/>
           </a:ln>
         </p:spPr>
+        <p:txBody>
+          <a:bodyPr/>
+          <a:lstStyle/>
+          <a:p>
+            <a:endParaRPr lang="es-CO"/>
+          </a:p>
+        </p:txBody>
       </p:sp>
       <p:sp>
         <p:nvSpPr>
@@ -6450,6 +8483,13 @@
             <a:prstDash val="solid"/>
           </a:ln>
         </p:spPr>
+        <p:txBody>
+          <a:bodyPr/>
+          <a:lstStyle/>
+          <a:p>
+            <a:endParaRPr lang="es-CO"/>
+          </a:p>
+        </p:txBody>
       </p:sp>
       <p:sp>
         <p:nvSpPr>
@@ -6560,6 +8600,13 @@
             </a:outerShdw>
           </a:effectLst>
         </p:spPr>
+        <p:txBody>
+          <a:bodyPr/>
+          <a:lstStyle/>
+          <a:p>
+            <a:endParaRPr lang="es-CO"/>
+          </a:p>
+        </p:txBody>
       </p:sp>
       <p:sp>
         <p:nvSpPr>
@@ -6585,6 +8632,13 @@
             <a:prstDash val="solid"/>
           </a:ln>
         </p:spPr>
+        <p:txBody>
+          <a:bodyPr/>
+          <a:lstStyle/>
+          <a:p>
+            <a:endParaRPr lang="es-CO"/>
+          </a:p>
+        </p:txBody>
       </p:sp>
       <p:sp>
         <p:nvSpPr>
@@ -6610,6 +8664,13 @@
             <a:prstDash val="solid"/>
           </a:ln>
         </p:spPr>
+        <p:txBody>
+          <a:bodyPr/>
+          <a:lstStyle/>
+          <a:p>
+            <a:endParaRPr lang="es-CO"/>
+          </a:p>
+        </p:txBody>
       </p:sp>
       <p:sp>
         <p:nvSpPr>
@@ -6793,6 +8854,13 @@
             </a:outerShdw>
           </a:effectLst>
         </p:spPr>
+        <p:txBody>
+          <a:bodyPr/>
+          <a:lstStyle/>
+          <a:p>
+            <a:endParaRPr lang="es-CO"/>
+          </a:p>
+        </p:txBody>
       </p:sp>
       <p:sp>
         <p:nvSpPr>
@@ -6818,6 +8886,13 @@
             <a:prstDash val="solid"/>
           </a:ln>
         </p:spPr>
+        <p:txBody>
+          <a:bodyPr/>
+          <a:lstStyle/>
+          <a:p>
+            <a:endParaRPr lang="es-CO"/>
+          </a:p>
+        </p:txBody>
       </p:sp>
       <p:sp>
         <p:nvSpPr>
@@ -6843,6 +8918,13 @@
             <a:prstDash val="solid"/>
           </a:ln>
         </p:spPr>
+        <p:txBody>
+          <a:bodyPr/>
+          <a:lstStyle/>
+          <a:p>
+            <a:endParaRPr lang="es-CO"/>
+          </a:p>
+        </p:txBody>
       </p:sp>
       <p:sp>
         <p:nvSpPr>
@@ -7026,6 +9108,13 @@
             </a:outerShdw>
           </a:effectLst>
         </p:spPr>
+        <p:txBody>
+          <a:bodyPr/>
+          <a:lstStyle/>
+          <a:p>
+            <a:endParaRPr lang="es-CO"/>
+          </a:p>
+        </p:txBody>
       </p:sp>
       <p:sp>
         <p:nvSpPr>
@@ -7051,6 +9140,13 @@
             <a:prstDash val="solid"/>
           </a:ln>
         </p:spPr>
+        <p:txBody>
+          <a:bodyPr/>
+          <a:lstStyle/>
+          <a:p>
+            <a:endParaRPr lang="es-CO"/>
+          </a:p>
+        </p:txBody>
       </p:sp>
       <p:sp>
         <p:nvSpPr>
@@ -7076,6 +9172,13 @@
             <a:prstDash val="solid"/>
           </a:ln>
         </p:spPr>
+        <p:txBody>
+          <a:bodyPr/>
+          <a:lstStyle/>
+          <a:p>
+            <a:endParaRPr lang="es-CO"/>
+          </a:p>
+        </p:txBody>
       </p:sp>
       <p:sp>
         <p:nvSpPr>
@@ -7259,6 +9362,13 @@
             </a:outerShdw>
           </a:effectLst>
         </p:spPr>
+        <p:txBody>
+          <a:bodyPr/>
+          <a:lstStyle/>
+          <a:p>
+            <a:endParaRPr lang="es-CO"/>
+          </a:p>
+        </p:txBody>
       </p:sp>
       <p:sp>
         <p:nvSpPr>
@@ -7284,6 +9394,13 @@
             <a:prstDash val="solid"/>
           </a:ln>
         </p:spPr>
+        <p:txBody>
+          <a:bodyPr/>
+          <a:lstStyle/>
+          <a:p>
+            <a:endParaRPr lang="es-CO"/>
+          </a:p>
+        </p:txBody>
       </p:sp>
       <p:sp>
         <p:nvSpPr>
@@ -7309,6 +9426,13 @@
             <a:prstDash val="solid"/>
           </a:ln>
         </p:spPr>
+        <p:txBody>
+          <a:bodyPr/>
+          <a:lstStyle/>
+          <a:p>
+            <a:endParaRPr lang="es-CO"/>
+          </a:p>
+        </p:txBody>
       </p:sp>
       <p:sp>
         <p:nvSpPr>
@@ -7453,6 +9577,13 @@
             </a:outerShdw>
           </a:effectLst>
         </p:spPr>
+        <p:txBody>
+          <a:bodyPr/>
+          <a:lstStyle/>
+          <a:p>
+            <a:endParaRPr lang="es-CO"/>
+          </a:p>
+        </p:txBody>
       </p:sp>
       <p:sp>
         <p:nvSpPr>
@@ -7478,6 +9609,13 @@
             <a:prstDash val="solid"/>
           </a:ln>
         </p:spPr>
+        <p:txBody>
+          <a:bodyPr/>
+          <a:lstStyle/>
+          <a:p>
+            <a:endParaRPr lang="es-CO"/>
+          </a:p>
+        </p:txBody>
       </p:sp>
       <p:sp>
         <p:nvSpPr>
@@ -7553,6 +9691,13 @@
             <a:prstDash val="solid"/>
           </a:ln>
         </p:spPr>
+        <p:txBody>
+          <a:bodyPr/>
+          <a:lstStyle/>
+          <a:p>
+            <a:endParaRPr lang="es-CO"/>
+          </a:p>
+        </p:txBody>
       </p:sp>
       <p:sp>
         <p:nvSpPr>
@@ -7693,6 +9838,13 @@
             <a:prstDash val="solid"/>
           </a:ln>
         </p:spPr>
+        <p:txBody>
+          <a:bodyPr/>
+          <a:lstStyle/>
+          <a:p>
+            <a:endParaRPr lang="es-CO"/>
+          </a:p>
+        </p:txBody>
       </p:sp>
       <p:sp>
         <p:nvSpPr>
@@ -7722,6 +9874,13 @@
             <a:prstDash val="solid"/>
           </a:ln>
         </p:spPr>
+        <p:txBody>
+          <a:bodyPr/>
+          <a:lstStyle/>
+          <a:p>
+            <a:endParaRPr lang="es-CO"/>
+          </a:p>
+        </p:txBody>
       </p:sp>
       <p:sp>
         <p:nvSpPr>
@@ -7747,6 +9906,13 @@
             <a:prstDash val="solid"/>
           </a:ln>
         </p:spPr>
+        <p:txBody>
+          <a:bodyPr/>
+          <a:lstStyle/>
+          <a:p>
+            <a:endParaRPr lang="es-CO"/>
+          </a:p>
+        </p:txBody>
       </p:sp>
       <p:sp>
         <p:nvSpPr>
@@ -7915,6 +10081,13 @@
             </a:outerShdw>
           </a:effectLst>
         </p:spPr>
+        <p:txBody>
+          <a:bodyPr/>
+          <a:lstStyle/>
+          <a:p>
+            <a:endParaRPr lang="es-CO"/>
+          </a:p>
+        </p:txBody>
       </p:sp>
       <p:sp>
         <p:nvSpPr>
@@ -8025,6 +10198,13 @@
             <a:prstDash val="solid"/>
           </a:ln>
         </p:spPr>
+        <p:txBody>
+          <a:bodyPr/>
+          <a:lstStyle/>
+          <a:p>
+            <a:endParaRPr lang="es-CO"/>
+          </a:p>
+        </p:txBody>
       </p:sp>
       <p:sp>
         <p:nvSpPr>
@@ -8162,6 +10342,13 @@
             <a:prstDash val="solid"/>
           </a:ln>
         </p:spPr>
+        <p:txBody>
+          <a:bodyPr/>
+          <a:lstStyle/>
+          <a:p>
+            <a:endParaRPr lang="es-CO"/>
+          </a:p>
+        </p:txBody>
       </p:sp>
       <p:sp>
         <p:nvSpPr>

</xml_diff>